<commit_message>
Update presentation: Arandu brand palette, lemniscata image, Google Slides variant
- Primary color updated to wine/burgundy (7B2230) matching arandu.com.br
- Slide 7 now embeds the matplotlib lemniscata diagram (7 stages curve)
- GSlides variant uses Arial throughout for Google Slides compatibility
- All charts and layout validated

Co-Authored-By: Claude <noreply@anthropic.com>
</commit_message>
<xml_diff>
--- a/Pesquisa_Comunidade_Arandu_2025.pptx
+++ b/Pesquisa_Comunidade_Arandu_2025.pptx
@@ -133,7 +133,7 @@
             <a:pPr>
               <a:defRPr sz="1200" b="0" i="0" u="none" strike="noStrike">
                 <a:solidFill>
-                  <a:srgbClr val="1B2B1E"/>
+                  <a:srgbClr val="1B2420"/>
                 </a:solidFill>
                 <a:latin typeface="Arial"/>
               </a:defRPr>
@@ -141,7 +141,7 @@
             <a:r>
               <a:rPr sz="1200" b="0" i="0" u="none" strike="noStrike">
                 <a:solidFill>
-                  <a:srgbClr val="1B2B1E"/>
+                  <a:srgbClr val="1B2420"/>
                 </a:solidFill>
                 <a:latin typeface="Arial"/>
               </a:rPr>
@@ -169,7 +169,7 @@
               <c:strCache>
                 <c:ptCount val="1"/>
                 <c:pt idx="0">
-                  <c:v>Respondentes</c:v>
+                  <c:v>%</c:v>
                 </c:pt>
               </c:strCache>
             </c:strRef>
@@ -190,7 +190,7 @@
                 <a:pPr>
                   <a:defRPr b="0" i="0" strike="noStrike" sz="900" u="none">
                     <a:solidFill>
-                      <a:srgbClr val="748C78"/>
+                      <a:srgbClr val="8A7070"/>
                     </a:solidFill>
                     <a:latin typeface="Arial"/>
                   </a:defRPr>
@@ -282,7 +282,7 @@
               <a:pPr>
                 <a:defRPr b="0" i="0" strike="noStrike" sz="900" u="none">
                   <a:solidFill>
-                    <a:srgbClr val="748C78"/>
+                    <a:srgbClr val="8A7070"/>
                   </a:solidFill>
                   <a:latin typeface="Arial"/>
                 </a:defRPr>
@@ -330,7 +330,7 @@
             <a:pPr>
               <a:defRPr sz="1000" b="0" i="0" u="none" strike="noStrike">
                 <a:solidFill>
-                  <a:srgbClr val="748C78"/>
+                  <a:srgbClr val="8A7070"/>
                 </a:solidFill>
                 <a:latin typeface="Arial"/>
               </a:defRPr>
@@ -421,7 +421,7 @@
             <a:pPr>
               <a:defRPr sz="1200" b="0" i="0" u="none" strike="noStrike">
                 <a:solidFill>
-                  <a:srgbClr val="1B2B1E"/>
+                  <a:srgbClr val="1B2420"/>
                 </a:solidFill>
                 <a:latin typeface="Arial"/>
               </a:defRPr>
@@ -429,7 +429,7 @@
             <a:r>
               <a:rPr sz="1200" b="0" i="0" u="none" strike="noStrike">
                 <a:solidFill>
-                  <a:srgbClr val="1B2B1E"/>
+                  <a:srgbClr val="1B2420"/>
                 </a:solidFill>
                 <a:latin typeface="Arial"/>
               </a:rPr>
@@ -464,7 +464,7 @@
           </c:tx>
           <c:spPr>
             <a:solidFill>
-              <a:srgbClr val="2D6A4F"/>
+              <a:srgbClr val="A83048"/>
             </a:solidFill>
             <a:effectLst/>
           </c:spPr>
@@ -478,7 +478,7 @@
                 <a:pPr>
                   <a:defRPr b="0" i="0" strike="noStrike" sz="900" u="none">
                     <a:solidFill>
-                      <a:srgbClr val="748C78"/>
+                      <a:srgbClr val="8A7070"/>
                     </a:solidFill>
                     <a:latin typeface="Arial"/>
                   </a:defRPr>
@@ -509,7 +509,7 @@
                     <c:v>Família recomposta</c:v>
                   </c:pt>
                   <c:pt idx="3">
-                    <c:v>Família estendida</c:v>
+                    <c:v>Estendida</c:v>
                   </c:pt>
                   <c:pt idx="4">
                     <c:v>Outros</c:v>
@@ -552,7 +552,7 @@
               <a:pPr>
                 <a:defRPr b="0" i="0" strike="noStrike" sz="900" u="none">
                   <a:solidFill>
-                    <a:srgbClr val="748C78"/>
+                    <a:srgbClr val="8A7070"/>
                   </a:solidFill>
                   <a:latin typeface="Arial"/>
                 </a:defRPr>
@@ -600,7 +600,7 @@
             <a:pPr>
               <a:defRPr sz="1000" b="0" i="0" u="none" strike="noStrike">
                 <a:solidFill>
-                  <a:srgbClr val="748C78"/>
+                  <a:srgbClr val="8A7070"/>
                 </a:solidFill>
                 <a:latin typeface="Arial"/>
               </a:defRPr>
@@ -691,7 +691,7 @@
             <a:pPr>
               <a:defRPr sz="1200" b="0" i="0" u="none" strike="noStrike">
                 <a:solidFill>
-                  <a:srgbClr val="1B2B1E"/>
+                  <a:srgbClr val="1B2420"/>
                 </a:solidFill>
                 <a:latin typeface="Arial"/>
               </a:defRPr>
@@ -699,7 +699,7 @@
             <a:r>
               <a:rPr sz="1200" b="0" i="0" u="none" strike="noStrike">
                 <a:solidFill>
-                  <a:srgbClr val="1B2B1E"/>
+                  <a:srgbClr val="1B2420"/>
                 </a:solidFill>
                 <a:latin typeface="Arial"/>
               </a:rPr>
@@ -748,7 +748,7 @@
                 <a:pPr>
                   <a:defRPr b="0" i="0" strike="noStrike" sz="900" u="none">
                     <a:solidFill>
-                      <a:srgbClr val="748C78"/>
+                      <a:srgbClr val="8A7070"/>
                     </a:solidFill>
                     <a:latin typeface="Arial"/>
                   </a:defRPr>
@@ -828,7 +828,7 @@
               <a:pPr>
                 <a:defRPr b="0" i="0" strike="noStrike" sz="900" u="none">
                   <a:solidFill>
-                    <a:srgbClr val="748C78"/>
+                    <a:srgbClr val="8A7070"/>
                   </a:solidFill>
                   <a:latin typeface="Arial"/>
                 </a:defRPr>
@@ -876,7 +876,7 @@
             <a:pPr>
               <a:defRPr sz="1000" b="0" i="0" u="none" strike="noStrike">
                 <a:solidFill>
-                  <a:srgbClr val="748C78"/>
+                  <a:srgbClr val="8A7070"/>
                 </a:solidFill>
                 <a:latin typeface="Arial"/>
               </a:defRPr>
@@ -967,7 +967,7 @@
             <a:pPr>
               <a:defRPr sz="1200" b="0" i="0" u="none" strike="noStrike">
                 <a:solidFill>
-                  <a:srgbClr val="1B2B1E"/>
+                  <a:srgbClr val="1B2420"/>
                 </a:solidFill>
                 <a:latin typeface="Arial"/>
               </a:defRPr>
@@ -975,7 +975,7 @@
             <a:r>
               <a:rPr sz="1200" b="0" i="0" u="none" strike="noStrike">
                 <a:solidFill>
-                  <a:srgbClr val="1B2B1E"/>
+                  <a:srgbClr val="1B2420"/>
                 </a:solidFill>
                 <a:latin typeface="Arial"/>
               </a:rPr>
@@ -1003,14 +1003,14 @@
               <c:strCache>
                 <c:ptCount val="1"/>
                 <c:pt idx="0">
-                  <c:v>Respondentes</c:v>
+                  <c:v>N</c:v>
                 </c:pt>
               </c:strCache>
             </c:strRef>
           </c:tx>
           <c:spPr>
             <a:solidFill>
-              <a:srgbClr val="52B788"/>
+              <a:srgbClr val="2D6A4F"/>
             </a:solidFill>
             <a:effectLst/>
           </c:spPr>
@@ -1024,7 +1024,7 @@
                 <a:pPr>
                   <a:defRPr b="0" i="0" strike="noStrike" sz="900" u="none">
                     <a:solidFill>
-                      <a:srgbClr val="748C78"/>
+                      <a:srgbClr val="8A7070"/>
                     </a:solidFill>
                     <a:latin typeface="Arial"/>
                   </a:defRPr>
@@ -1135,7 +1135,7 @@
               <a:pPr>
                 <a:defRPr b="0" i="0" strike="noStrike" sz="900" u="none">
                   <a:solidFill>
-                    <a:srgbClr val="748C78"/>
+                    <a:srgbClr val="8A7070"/>
                   </a:solidFill>
                   <a:latin typeface="Arial"/>
                 </a:defRPr>
@@ -1183,7 +1183,7 @@
             <a:pPr>
               <a:defRPr sz="900" b="0" i="0" u="none" strike="noStrike">
                 <a:solidFill>
-                  <a:srgbClr val="748C78"/>
+                  <a:srgbClr val="8A7070"/>
                 </a:solidFill>
                 <a:latin typeface="Arial"/>
               </a:defRPr>
@@ -1360,7 +1360,7 @@
           </c:tx>
           <c:spPr>
             <a:solidFill>
-              <a:srgbClr val="F4845F"/>
+              <a:srgbClr val="C04060"/>
             </a:solidFill>
             <a:effectLst/>
           </c:spPr>
@@ -1833,7 +1833,7 @@
           <a:pPr>
             <a:defRPr sz="1100">
               <a:solidFill>
-                <a:srgbClr val="1B2B1E"/>
+                <a:srgbClr val="1B2420"/>
               </a:solidFill>
             </a:defRPr>
           </a:pPr>
@@ -1883,11 +1883,11 @@
           </c:tx>
           <c:spPr>
             <a:solidFill>
-              <a:srgbClr val="2A9D8F"/>
+              <a:srgbClr val="A83048"/>
             </a:solidFill>
             <a:ln w="31750" cap="flat">
               <a:solidFill>
-                <a:srgbClr val="2A9D8F"/>
+                <a:srgbClr val="A83048"/>
               </a:solidFill>
               <a:prstDash val="solid"/>
               <a:round/>
@@ -1904,7 +1904,7 @@
                 <a:pPr>
                   <a:defRPr b="0" i="0" strike="noStrike" sz="900" u="none">
                     <a:solidFill>
-                      <a:srgbClr val="748C78"/>
+                      <a:srgbClr val="8A7070"/>
                     </a:solidFill>
                     <a:latin typeface="Arial"/>
                   </a:defRPr>
@@ -1924,11 +1924,11 @@
             <c:size val="6"/>
             <c:spPr>
               <a:solidFill>
-                <a:srgbClr val="2A9D8F"/>
+                <a:srgbClr val="A83048"/>
               </a:solidFill>
               <a:ln w="9525" cap="flat">
                 <a:solidFill>
-                  <a:srgbClr val="2A9D8F"/>
+                  <a:srgbClr val="A83048"/>
                 </a:solidFill>
                 <a:prstDash val="solid"/>
                 <a:round/>
@@ -1997,11 +1997,11 @@
           </c:tx>
           <c:spPr>
             <a:solidFill>
-              <a:srgbClr val="1D5B7A"/>
+              <a:srgbClr val="2D6A4F"/>
             </a:solidFill>
             <a:ln w="31750" cap="flat">
               <a:solidFill>
-                <a:srgbClr val="1D5B7A"/>
+                <a:srgbClr val="2D6A4F"/>
               </a:solidFill>
               <a:prstDash val="solid"/>
               <a:round/>
@@ -2018,7 +2018,7 @@
                 <a:pPr>
                   <a:defRPr b="0" i="0" strike="noStrike" sz="900" u="none">
                     <a:solidFill>
-                      <a:srgbClr val="748C78"/>
+                      <a:srgbClr val="8A7070"/>
                     </a:solidFill>
                     <a:latin typeface="Arial"/>
                   </a:defRPr>
@@ -2038,11 +2038,11 @@
             <c:size val="6"/>
             <c:spPr>
               <a:solidFill>
-                <a:srgbClr val="1D5B7A"/>
+                <a:srgbClr val="2D6A4F"/>
               </a:solidFill>
               <a:ln w="9525" cap="flat">
                 <a:solidFill>
-                  <a:srgbClr val="1D5B7A"/>
+                  <a:srgbClr val="2D6A4F"/>
                 </a:solidFill>
                 <a:prstDash val="solid"/>
                 <a:round/>
@@ -2111,11 +2111,11 @@
           </c:tx>
           <c:spPr>
             <a:solidFill>
-              <a:srgbClr val="F4845F"/>
+              <a:srgbClr val="457B9D"/>
             </a:solidFill>
             <a:ln w="31750" cap="flat">
               <a:solidFill>
-                <a:srgbClr val="F4845F"/>
+                <a:srgbClr val="457B9D"/>
               </a:solidFill>
               <a:prstDash val="solid"/>
               <a:round/>
@@ -2132,7 +2132,7 @@
                 <a:pPr>
                   <a:defRPr b="0" i="0" strike="noStrike" sz="900" u="none">
                     <a:solidFill>
-                      <a:srgbClr val="748C78"/>
+                      <a:srgbClr val="8A7070"/>
                     </a:solidFill>
                     <a:latin typeface="Arial"/>
                   </a:defRPr>
@@ -2152,11 +2152,11 @@
             <c:size val="6"/>
             <c:spPr>
               <a:solidFill>
-                <a:srgbClr val="F4845F"/>
+                <a:srgbClr val="457B9D"/>
               </a:solidFill>
               <a:ln w="9525" cap="flat">
                 <a:solidFill>
-                  <a:srgbClr val="F4845F"/>
+                  <a:srgbClr val="457B9D"/>
                 </a:solidFill>
                 <a:prstDash val="solid"/>
                 <a:round/>
@@ -2246,7 +2246,7 @@
                 <a:pPr>
                   <a:defRPr b="0" i="0" strike="noStrike" sz="900" u="none">
                     <a:solidFill>
-                      <a:srgbClr val="748C78"/>
+                      <a:srgbClr val="8A7070"/>
                     </a:solidFill>
                     <a:latin typeface="Arial"/>
                   </a:defRPr>
@@ -2360,7 +2360,7 @@
                 <a:pPr>
                   <a:defRPr b="0" i="0" strike="noStrike" sz="900" u="none">
                     <a:solidFill>
-                      <a:srgbClr val="748C78"/>
+                      <a:srgbClr val="8A7070"/>
                     </a:solidFill>
                     <a:latin typeface="Arial"/>
                   </a:defRPr>
@@ -2446,7 +2446,7 @@
               <a:pPr>
                 <a:defRPr b="0" i="0" strike="noStrike" sz="900" u="none">
                   <a:solidFill>
-                    <a:srgbClr val="748C78"/>
+                    <a:srgbClr val="8A7070"/>
                   </a:solidFill>
                   <a:latin typeface="Arial"/>
                 </a:defRPr>
@@ -2493,7 +2493,7 @@
             <a:pPr>
               <a:defRPr sz="1200" b="0" i="0" u="none" strike="noStrike">
                 <a:solidFill>
-                  <a:srgbClr val="1B2B1E"/>
+                  <a:srgbClr val="1B2420"/>
                 </a:solidFill>
                 <a:latin typeface="Arial"/>
               </a:defRPr>
@@ -2520,7 +2520,7 @@
           <c:spPr>
             <a:ln w="6350" cap="flat">
               <a:solidFill>
-                <a:srgbClr val="E5E7EB"/>
+                <a:srgbClr val="E5E0DC"/>
               </a:solidFill>
               <a:prstDash val="solid"/>
               <a:round/>
@@ -2547,7 +2547,7 @@
             <a:pPr>
               <a:defRPr sz="1000" b="0" i="0" u="none" strike="noStrike">
                 <a:solidFill>
-                  <a:srgbClr val="748C78"/>
+                  <a:srgbClr val="8A7070"/>
                 </a:solidFill>
                 <a:latin typeface="Arial"/>
               </a:defRPr>
@@ -2577,7 +2577,7 @@
           <a:pPr>
             <a:defRPr sz="1000">
               <a:solidFill>
-                <a:srgbClr val="1B2B1E"/>
+                <a:srgbClr val="1B2420"/>
               </a:solidFill>
             </a:defRPr>
           </a:pPr>
@@ -2629,7 +2629,7 @@
           </c:tx>
           <c:spPr>
             <a:solidFill>
-              <a:srgbClr val="2A9D8F"/>
+              <a:srgbClr val="2D6A4F"/>
             </a:solidFill>
             <a:effectLst/>
           </c:spPr>
@@ -2643,7 +2643,7 @@
                 <a:pPr>
                   <a:defRPr b="0" i="0" strike="noStrike" sz="1000" u="none">
                     <a:solidFill>
-                      <a:srgbClr val="1B2B1E"/>
+                      <a:srgbClr val="1B2420"/>
                     </a:solidFill>
                     <a:latin typeface="Arial"/>
                   </a:defRPr>
@@ -2719,7 +2719,7 @@
           </c:tx>
           <c:spPr>
             <a:solidFill>
-              <a:srgbClr val="F4A828"/>
+              <a:srgbClr val="D4821A"/>
             </a:solidFill>
             <a:effectLst/>
           </c:spPr>
@@ -2733,7 +2733,7 @@
                 <a:pPr>
                   <a:defRPr b="0" i="0" strike="noStrike" sz="1000" u="none">
                     <a:solidFill>
-                      <a:srgbClr val="1B2B1E"/>
+                      <a:srgbClr val="1B2420"/>
                     </a:solidFill>
                     <a:latin typeface="Arial"/>
                   </a:defRPr>
@@ -2809,7 +2809,7 @@
           </c:tx>
           <c:spPr>
             <a:solidFill>
-              <a:srgbClr val="E0E0E0"/>
+              <a:srgbClr val="E8DDD8"/>
             </a:solidFill>
             <a:effectLst/>
           </c:spPr>
@@ -2823,7 +2823,7 @@
                 <a:pPr>
                   <a:defRPr b="0" i="0" strike="noStrike" sz="1000" u="none">
                     <a:solidFill>
-                      <a:srgbClr val="1B2B1E"/>
+                      <a:srgbClr val="1B2420"/>
                     </a:solidFill>
                     <a:latin typeface="Arial"/>
                   </a:defRPr>
@@ -2892,7 +2892,7 @@
               <a:pPr>
                 <a:defRPr b="0" i="0" strike="noStrike" sz="1000" u="none">
                   <a:solidFill>
-                    <a:srgbClr val="1B2B1E"/>
+                    <a:srgbClr val="1B2420"/>
                   </a:solidFill>
                   <a:latin typeface="Arial"/>
                 </a:defRPr>
@@ -2941,7 +2941,7 @@
             <a:pPr>
               <a:defRPr sz="1200" b="0" i="0" u="none" strike="noStrike">
                 <a:solidFill>
-                  <a:srgbClr val="1B2B1E"/>
+                  <a:srgbClr val="1B2420"/>
                 </a:solidFill>
                 <a:latin typeface="Arial"/>
               </a:defRPr>
@@ -3012,7 +3012,7 @@
           <a:pPr>
             <a:defRPr sz="1100">
               <a:solidFill>
-                <a:srgbClr val="1B2B1E"/>
+                <a:srgbClr val="1B2420"/>
               </a:solidFill>
             </a:defRPr>
           </a:pPr>
@@ -3057,14 +3057,14 @@
               <c:strCache>
                 <c:ptCount val="1"/>
                 <c:pt idx="0">
-                  <c:v>Respondentes</c:v>
+                  <c:v>%</c:v>
                 </c:pt>
               </c:strCache>
             </c:strRef>
           </c:tx>
           <c:spPr>
             <a:solidFill>
-              <a:srgbClr val="52B788"/>
+              <a:srgbClr val="2D6A4F"/>
             </a:solidFill>
             <a:effectLst/>
           </c:spPr>
@@ -3078,7 +3078,7 @@
                 <a:pPr>
                   <a:defRPr b="0" i="0" strike="noStrike" sz="1000" u="none">
                     <a:solidFill>
-                      <a:srgbClr val="748C78"/>
+                      <a:srgbClr val="8A7070"/>
                     </a:solidFill>
                     <a:latin typeface="Arial"/>
                   </a:defRPr>
@@ -3099,7 +3099,7 @@
             <c:bubble3D val="0"/>
             <c:spPr>
               <a:solidFill>
-                <a:srgbClr val="52B788"/>
+                <a:srgbClr val="2D6A4F"/>
               </a:solidFill>
               <a:effectLst/>
             </c:spPr>
@@ -3110,7 +3110,7 @@
             <c:bubble3D val="0"/>
             <c:spPr>
               <a:solidFill>
-                <a:srgbClr val="3B82C4"/>
+                <a:srgbClr val="457B9D"/>
               </a:solidFill>
               <a:effectLst/>
             </c:spPr>
@@ -3121,7 +3121,7 @@
             <c:bubble3D val="0"/>
             <c:spPr>
               <a:solidFill>
-                <a:srgbClr val="3B82C4"/>
+                <a:srgbClr val="457B9D"/>
               </a:solidFill>
               <a:effectLst/>
             </c:spPr>
@@ -3132,7 +3132,7 @@
             <c:bubble3D val="0"/>
             <c:spPr>
               <a:solidFill>
-                <a:srgbClr val="D4821A"/>
+                <a:srgbClr val="A83048"/>
               </a:solidFill>
               <a:effectLst/>
             </c:spPr>
@@ -3143,7 +3143,7 @@
             <c:bubble3D val="0"/>
             <c:spPr>
               <a:solidFill>
-                <a:srgbClr val="D4821A"/>
+                <a:srgbClr val="A83048"/>
               </a:solidFill>
               <a:effectLst/>
             </c:spPr>
@@ -3207,7 +3207,7 @@
               <a:pPr>
                 <a:defRPr b="0" i="0" strike="noStrike" sz="1000" u="none">
                   <a:solidFill>
-                    <a:srgbClr val="748C78"/>
+                    <a:srgbClr val="8A7070"/>
                   </a:solidFill>
                   <a:latin typeface="Arial"/>
                 </a:defRPr>
@@ -3255,7 +3255,7 @@
             <a:pPr>
               <a:defRPr sz="1000" b="0" i="0" u="none" strike="noStrike">
                 <a:solidFill>
-                  <a:srgbClr val="1B2B1E"/>
+                  <a:srgbClr val="1B2420"/>
                 </a:solidFill>
                 <a:latin typeface="Arial"/>
               </a:defRPr>
@@ -3815,7 +3815,7 @@
           <a:p>
             <a:r>
               <a:rPr lang="en-US" dirty="0"/>
-              <a:t>Engajamento ativo é o diferencial: sobe de 5-8% nos comprometidos para 57% nos Embaixadores+Cocriadores. Pertencimento é consistentemente alto em todos os grupos. Conhecimento Institucional tem lacuna mesmo em grupos avançados.</a:t>
+              <a:t>Engajamento ativo é o principal diferencial: cresce de 5–8% nos comprometidos para 57% em Embaixador+Cocriador. Pertencimento é alto em todos os grupos.</a:t>
             </a:r>
             <a:endParaRPr lang="en-US" dirty="0"/>
           </a:p>
@@ -3903,7 +3903,7 @@
           <a:p>
             <a:r>
               <a:rPr lang="en-US" dirty="0"/>
-              <a:t>Padrão claro: quanto mais avançado na curva, maior o engajamento ativo. 64% dos Inserindos nunca participaram de papel algum. Comprometidos têm histórico de participação (49% já foram), mas poucos (5%) são atualmente ativos.</a:t>
+              <a:t>64% dos Inserindos nunca participaram de papel algum. Comprometidos têm histórico (49% já foram), mas poucos são ativos agora (5%). O engajamento sobe muito apenas nos estágios avançados.</a:t>
             </a:r>
             <a:endParaRPr lang="en-US" dirty="0"/>
           </a:p>
@@ -3991,7 +3991,7 @@
           <a:p>
             <a:r>
               <a:rPr lang="en-US" dirty="0"/>
-              <a:t>42% têm potencial não declarado — as respostas mostram nível acima do que declaram. 30% se posicionam acima do que as respostas sustentam. Apenas 27% estão alinhados.</a:t>
+              <a:t>42% têm potencial não declarado — as respostas mostram nível acima do que declaram. 30% se posicionam acima do que as respostas sustentam. 27% alinhados.</a:t>
             </a:r>
             <a:endParaRPr lang="en-US" dirty="0"/>
           </a:p>
@@ -4079,7 +4079,7 @@
           <a:p>
             <a:r>
               <a:rPr lang="en-US" dirty="0"/>
-              <a:t>Próximos passos: aprofundar análise qualitativa dos Inserindos; criar espaços de reconhecimento para Comprometidos; desenhar convites de engajamento por nível de maturidade.</a:t>
+              <a:t/>
             </a:r>
             <a:endParaRPr lang="en-US" dirty="0"/>
           </a:p>
@@ -4255,7 +4255,7 @@
           <a:p>
             <a:r>
               <a:rPr lang="en-US" dirty="0"/>
-              <a:t>Comunidade majoritariamente feminina (60%), madura (média 43 anos) e altamente escolarizada (89% com superior ou pós).</a:t>
+              <a:t>Comunidade majoritariamente feminina (60%), madura (43 anos em média) e altamente escolarizada (89% com superior ou pós).</a:t>
             </a:r>
             <a:endParaRPr lang="en-US" dirty="0"/>
           </a:p>
@@ -4343,7 +4343,7 @@
           <a:p>
             <a:r>
               <a:rPr lang="en-US" dirty="0"/>
-              <a:t>68% famílias biparentais. Renda concentrada entre 3 e 10 SM (57.4%). 40.6% alugam imóvel. 80% praticam doação (regular ou ocasional).</a:t>
+              <a:t>68% famílias biparentais. Renda concentrada entre 3 e 10 SM (57,4%). 40,6% alugam imóvel. 80% praticam alguma forma de doação.</a:t>
             </a:r>
             <a:endParaRPr lang="en-US" dirty="0"/>
           </a:p>
@@ -4431,7 +4431,7 @@
           <a:p>
             <a:r>
               <a:rPr lang="en-US" dirty="0"/>
-              <a:t>Pico de 38 novos em 2025. Comunidade com boa renovação. Apenas 33% têm formação em antroposofia — maioria no Seminário Pedagogia Waldorf.</a:t>
+              <a:t>Pico de 38 novos em 2025. Apenas 33% têm formação em antroposofia — a maioria no Seminário Pedagogia Waldorf.</a:t>
             </a:r>
             <a:endParaRPr lang="en-US" dirty="0"/>
           </a:p>
@@ -4519,7 +4519,7 @@
           <a:p>
             <a:r>
               <a:rPr lang="en-US" dirty="0"/>
-              <a:t>Seção 2: foco na curva dos 7 Processos Sociais — conceito antroposófico, metodologia de inferência e análise de resultados.</a:t>
+              <a:t/>
             </a:r>
             <a:endParaRPr lang="en-US" dirty="0"/>
           </a:p>
@@ -4607,7 +4607,7 @@
           <a:p>
             <a:r>
               <a:rPr lang="en-US" dirty="0"/>
-              <a:t>O estágio Comprometido é o "ponto de virada": a pessoa decide dizer SIM para os princípios e processos da escola. Antes desse ponto, a jornada é de reconhecimento individual; após, é de contribuição comunitária.</a:t>
+              <a:t>Antes do Comprometido: Capital Social Individual (o que a escola faz por mim). Após: Capital Social da Comunidade (o que faço pela escola). O "SIM" é a decisão que separa os dois lados da lemniscata.</a:t>
             </a:r>
             <a:endParaRPr lang="en-US" dirty="0"/>
           </a:p>
@@ -4695,7 +4695,7 @@
           <a:p>
             <a:r>
               <a:rPr lang="en-US" dirty="0"/>
-              <a:t>A inferência não substitui a autopercepção — é um complemento baseado em evidências das respostas. O modificador de tempo reflete que o amadurecimento na curva leva tempo real.</a:t>
+              <a:t>A inferência é complemento à autopercepção — não a substitui. O modificador de tempo reflete que o amadurecimento na curva leva tempo real.</a:t>
             </a:r>
             <a:endParaRPr lang="en-US" dirty="0"/>
           </a:p>
@@ -4783,7 +4783,7 @@
           <a:p>
             <a:r>
               <a:rPr lang="en-US" dirty="0"/>
-              <a:t>Destaque: 44,8% Comprometidos — disseram SIM para a escola. 32,2% em Inserindo — no ponto de virada. Apenas 16,4% em estágios ativos (Ativo, Embaixador, Cocriador).</a:t>
+              <a:t>Destaque: 44,8% Comprometidos — disseram SIM. 32,2% em Inserindo — no ponto de decisão. Apenas 16,4% em estágios ativos.</a:t>
             </a:r>
             <a:endParaRPr lang="en-US" dirty="0"/>
           </a:p>
@@ -5138,7 +5138,7 @@
     <p:bg>
       <p:bgPr>
         <a:solidFill>
-          <a:srgbClr val="1B4332"/>
+          <a:srgbClr val="5C1528"/>
         </a:solidFill>
       </p:bgPr>
     </p:bg>
@@ -5185,9 +5185,9 @@
                 <a:solidFill>
                   <a:srgbClr val="52B788"/>
                 </a:solidFill>
-                <a:latin typeface="Calibri" pitchFamily="34" charset="0"/>
-                <a:ea typeface="Calibri" pitchFamily="34" charset="-122"/>
-                <a:cs typeface="Calibri" pitchFamily="34" charset="-120"/>
+                <a:latin typeface="Arial" pitchFamily="34" charset="0"/>
+                <a:ea typeface="Arial" pitchFamily="34" charset="-122"/>
+                <a:cs typeface="Arial" pitchFamily="34" charset="-120"/>
               </a:rPr>
               <a:t>ESCOLA ARANDU</a:t>
             </a:r>
@@ -5204,7 +5204,7 @@
         <p:spPr>
           <a:xfrm>
             <a:off x="548640" y="960120"/>
-            <a:ext cx="6400800" cy="1828800"/>
+            <a:ext cx="6583680" cy="1828800"/>
           </a:xfrm>
           <a:prstGeom prst="rect">
             <a:avLst/>
@@ -5286,9 +5286,9 @@
                 <a:solidFill>
                   <a:srgbClr val="D4821A"/>
                 </a:solidFill>
-                <a:latin typeface="Calibri" pitchFamily="34" charset="0"/>
-                <a:ea typeface="Calibri" pitchFamily="34" charset="-122"/>
-                <a:cs typeface="Calibri" pitchFamily="34" charset="-120"/>
+                <a:latin typeface="Arial" pitchFamily="34" charset="0"/>
+                <a:ea typeface="Arial" pitchFamily="34" charset="-122"/>
+                <a:cs typeface="Arial" pitchFamily="34" charset="-120"/>
               </a:rPr>
               <a:t>Diagnóstico de Perfil Socioeconômico</a:t>
             </a:r>
@@ -5303,9 +5303,9 @@
                 <a:solidFill>
                   <a:srgbClr val="D4821A"/>
                 </a:solidFill>
-                <a:latin typeface="Calibri" pitchFamily="34" charset="0"/>
-                <a:ea typeface="Calibri" pitchFamily="34" charset="-122"/>
-                <a:cs typeface="Calibri" pitchFamily="34" charset="-120"/>
+                <a:latin typeface="Arial" pitchFamily="34" charset="0"/>
+                <a:ea typeface="Arial" pitchFamily="34" charset="-122"/>
+                <a:cs typeface="Arial" pitchFamily="34" charset="-120"/>
               </a:rPr>
               <a:t>e Engajamento na Curva dos 7 Processos Sociais</a:t>
             </a:r>
@@ -5328,11 +5328,11 @@
             <a:avLst/>
           </a:prstGeom>
           <a:solidFill>
-            <a:srgbClr val="2D6A4F"/>
+            <a:srgbClr val="7B2230"/>
           </a:solidFill>
           <a:ln w="12700">
             <a:solidFill>
-              <a:srgbClr val="2D6A4F"/>
+              <a:srgbClr val="7B2230"/>
             </a:solidFill>
             <a:prstDash val="solid"/>
           </a:ln>
@@ -5365,7 +5365,7 @@
             <a:r>
               <a:rPr lang="en-US" sz="2400" b="1" dirty="0">
                 <a:solidFill>
-                  <a:srgbClr val="F4A828"/>
+                  <a:srgbClr val="F4C060"/>
                 </a:solidFill>
                 <a:latin typeface="Cambria" pitchFamily="34" charset="0"/>
                 <a:ea typeface="Cambria" pitchFamily="34" charset="-122"/>
@@ -5404,11 +5404,11 @@
             <a:r>
               <a:rPr lang="en-US" sz="1000" dirty="0">
                 <a:solidFill>
-                  <a:srgbClr val="B7E4C7"/>
-                </a:solidFill>
-                <a:latin typeface="Calibri" pitchFamily="34" charset="0"/>
-                <a:ea typeface="Calibri" pitchFamily="34" charset="-122"/>
-                <a:cs typeface="Calibri" pitchFamily="34" charset="-120"/>
+                  <a:srgbClr val="E8D5D0"/>
+                </a:solidFill>
+                <a:latin typeface="Arial" pitchFamily="34" charset="0"/>
+                <a:ea typeface="Arial" pitchFamily="34" charset="-122"/>
+                <a:cs typeface="Arial" pitchFamily="34" charset="-120"/>
               </a:rPr>
               <a:t>respondentes</a:t>
             </a:r>
@@ -5431,11 +5431,11 @@
             <a:avLst/>
           </a:prstGeom>
           <a:solidFill>
-            <a:srgbClr val="2D6A4F"/>
+            <a:srgbClr val="7B2230"/>
           </a:solidFill>
           <a:ln w="12700">
             <a:solidFill>
-              <a:srgbClr val="2D6A4F"/>
+              <a:srgbClr val="7B2230"/>
             </a:solidFill>
             <a:prstDash val="solid"/>
           </a:ln>
@@ -5468,7 +5468,7 @@
             <a:r>
               <a:rPr lang="en-US" sz="2400" b="1" dirty="0">
                 <a:solidFill>
-                  <a:srgbClr val="F4A828"/>
+                  <a:srgbClr val="F4C060"/>
                 </a:solidFill>
                 <a:latin typeface="Cambria" pitchFamily="34" charset="0"/>
                 <a:ea typeface="Cambria" pitchFamily="34" charset="-122"/>
@@ -5507,11 +5507,11 @@
             <a:r>
               <a:rPr lang="en-US" sz="1000" dirty="0">
                 <a:solidFill>
-                  <a:srgbClr val="B7E4C7"/>
-                </a:solidFill>
-                <a:latin typeface="Calibri" pitchFamily="34" charset="0"/>
-                <a:ea typeface="Calibri" pitchFamily="34" charset="-122"/>
-                <a:cs typeface="Calibri" pitchFamily="34" charset="-120"/>
+                  <a:srgbClr val="E8D5D0"/>
+                </a:solidFill>
+                <a:latin typeface="Arial" pitchFamily="34" charset="0"/>
+                <a:ea typeface="Arial" pitchFamily="34" charset="-122"/>
+                <a:cs typeface="Arial" pitchFamily="34" charset="-120"/>
               </a:rPr>
               <a:t>coleta online</a:t>
             </a:r>
@@ -5534,11 +5534,11 @@
             <a:avLst/>
           </a:prstGeom>
           <a:solidFill>
-            <a:srgbClr val="2D6A4F"/>
+            <a:srgbClr val="7B2230"/>
           </a:solidFill>
           <a:ln w="12700">
             <a:solidFill>
-              <a:srgbClr val="2D6A4F"/>
+              <a:srgbClr val="7B2230"/>
             </a:solidFill>
             <a:prstDash val="solid"/>
           </a:ln>
@@ -5571,7 +5571,7 @@
             <a:r>
               <a:rPr lang="en-US" sz="2400" b="1" dirty="0">
                 <a:solidFill>
-                  <a:srgbClr val="F4A828"/>
+                  <a:srgbClr val="F4C060"/>
                 </a:solidFill>
                 <a:latin typeface="Cambria" pitchFamily="34" charset="0"/>
                 <a:ea typeface="Cambria" pitchFamily="34" charset="-122"/>
@@ -5610,11 +5610,11 @@
             <a:r>
               <a:rPr lang="en-US" sz="1000" dirty="0">
                 <a:solidFill>
-                  <a:srgbClr val="B7E4C7"/>
-                </a:solidFill>
-                <a:latin typeface="Calibri" pitchFamily="34" charset="0"/>
-                <a:ea typeface="Calibri" pitchFamily="34" charset="-122"/>
-                <a:cs typeface="Calibri" pitchFamily="34" charset="-120"/>
+                  <a:srgbClr val="E8D5D0"/>
+                </a:solidFill>
+                <a:latin typeface="Arial" pitchFamily="34" charset="0"/>
+                <a:ea typeface="Arial" pitchFamily="34" charset="-122"/>
+                <a:cs typeface="Arial" pitchFamily="34" charset="-120"/>
               </a:rPr>
               <a:t>dimensões</a:t>
             </a:r>
@@ -5637,11 +5637,11 @@
             <a:avLst/>
           </a:prstGeom>
           <a:solidFill>
-            <a:srgbClr val="2D6A4F"/>
+            <a:srgbClr val="7B2230"/>
           </a:solidFill>
           <a:ln w="12700">
             <a:solidFill>
-              <a:srgbClr val="2D6A4F"/>
+              <a:srgbClr val="7B2230"/>
             </a:solidFill>
             <a:prstDash val="solid"/>
           </a:ln>
@@ -5674,7 +5674,7 @@
             <a:r>
               <a:rPr lang="en-US" sz="2400" b="1" dirty="0">
                 <a:solidFill>
-                  <a:srgbClr val="F4A828"/>
+                  <a:srgbClr val="F4C060"/>
                 </a:solidFill>
                 <a:latin typeface="Cambria" pitchFamily="34" charset="0"/>
                 <a:ea typeface="Cambria" pitchFamily="34" charset="-122"/>
@@ -5713,11 +5713,11 @@
             <a:r>
               <a:rPr lang="en-US" sz="1000" dirty="0">
                 <a:solidFill>
-                  <a:srgbClr val="B7E4C7"/>
-                </a:solidFill>
-                <a:latin typeface="Calibri" pitchFamily="34" charset="0"/>
-                <a:ea typeface="Calibri" pitchFamily="34" charset="-122"/>
-                <a:cs typeface="Calibri" pitchFamily="34" charset="-120"/>
+                  <a:srgbClr val="E8D5D0"/>
+                </a:solidFill>
+                <a:latin typeface="Arial" pitchFamily="34" charset="0"/>
+                <a:ea typeface="Arial" pitchFamily="34" charset="-122"/>
+                <a:cs typeface="Arial" pitchFamily="34" charset="-120"/>
               </a:rPr>
               <a:t>estágios da curva</a:t>
             </a:r>
@@ -5784,7 +5784,7 @@
             <a:r>
               <a:rPr lang="en-US" sz="2600" b="1" dirty="0">
                 <a:solidFill>
-                  <a:srgbClr val="1B4332"/>
+                  <a:srgbClr val="7B2230"/>
                 </a:solidFill>
                 <a:latin typeface="Cambria" pitchFamily="34" charset="0"/>
                 <a:ea typeface="Cambria" pitchFamily="34" charset="-122"/>
@@ -5823,13 +5823,13 @@
             <a:r>
               <a:rPr lang="en-US" sz="1200" i="1" dirty="0">
                 <a:solidFill>
-                  <a:srgbClr val="748C78"/>
-                </a:solidFill>
-                <a:latin typeface="Calibri" pitchFamily="34" charset="0"/>
-                <a:ea typeface="Calibri" pitchFamily="34" charset="-122"/>
-                <a:cs typeface="Calibri" pitchFamily="34" charset="-120"/>
-              </a:rPr>
-              <a:t>% de respostas positivas (Concordo + Concordo parcialmente) por esfera e grupo</a:t>
+                  <a:srgbClr val="8A7070"/>
+                </a:solidFill>
+                <a:latin typeface="Arial" pitchFamily="34" charset="0"/>
+                <a:ea typeface="Arial" pitchFamily="34" charset="-122"/>
+                <a:cs typeface="Arial" pitchFamily="34" charset="-120"/>
+              </a:rPr>
+              <a:t>% de respostas positivas por esfera — agrupado por nível (exclui Adaptando, n=1)</a:t>
             </a:r>
             <a:endParaRPr lang="en-US" sz="1200" dirty="0"/>
           </a:p>
@@ -5910,7 +5910,7 @@
             <a:r>
               <a:rPr lang="en-US" sz="2600" b="1" dirty="0">
                 <a:solidFill>
-                  <a:srgbClr val="1B4332"/>
+                  <a:srgbClr val="7B2230"/>
                 </a:solidFill>
                 <a:latin typeface="Cambria" pitchFamily="34" charset="0"/>
                 <a:ea typeface="Cambria" pitchFamily="34" charset="-122"/>
@@ -5949,13 +5949,13 @@
             <a:r>
               <a:rPr lang="en-US" sz="1200" i="1" dirty="0">
                 <a:solidFill>
-                  <a:srgbClr val="748C78"/>
-                </a:solidFill>
-                <a:latin typeface="Calibri" pitchFamily="34" charset="0"/>
-                <a:ea typeface="Calibri" pitchFamily="34" charset="-122"/>
-                <a:cs typeface="Calibri" pitchFamily="34" charset="-120"/>
-              </a:rPr>
-              <a:t>% que declarou cada situação em relação a 5 papéis na escola — por nível inferido</a:t>
+                  <a:srgbClr val="8A7070"/>
+                </a:solidFill>
+                <a:latin typeface="Arial" pitchFamily="34" charset="0"/>
+                <a:ea typeface="Arial" pitchFamily="34" charset="-122"/>
+                <a:cs typeface="Arial" pitchFamily="34" charset="-120"/>
+              </a:rPr>
+              <a:t>% de cada situação em relação a 5 papéis na escola — por nível inferido</a:t>
             </a:r>
             <a:endParaRPr lang="en-US" sz="1200" dirty="0"/>
           </a:p>
@@ -6036,7 +6036,7 @@
             <a:r>
               <a:rPr lang="en-US" sz="2600" b="1" dirty="0">
                 <a:solidFill>
-                  <a:srgbClr val="1B4332"/>
+                  <a:srgbClr val="7B2230"/>
                 </a:solidFill>
                 <a:latin typeface="Cambria" pitchFamily="34" charset="0"/>
                 <a:ea typeface="Cambria" pitchFamily="34" charset="-122"/>
@@ -6075,13 +6075,13 @@
             <a:r>
               <a:rPr lang="en-US" sz="1200" i="1" dirty="0">
                 <a:solidFill>
-                  <a:srgbClr val="748C78"/>
-                </a:solidFill>
-                <a:latin typeface="Calibri" pitchFamily="34" charset="0"/>
-                <a:ea typeface="Calibri" pitchFamily="34" charset="-122"/>
-                <a:cs typeface="Calibri" pitchFamily="34" charset="-120"/>
-              </a:rPr>
-              <a:t>Comparação entre o estágio declarado na Q10 e o estágio inferido pelas respostas</a:t>
+                  <a:srgbClr val="8A7070"/>
+                </a:solidFill>
+                <a:latin typeface="Arial" pitchFamily="34" charset="0"/>
+                <a:ea typeface="Arial" pitchFamily="34" charset="-122"/>
+                <a:cs typeface="Arial" pitchFamily="34" charset="-120"/>
+              </a:rPr>
+              <a:t>Comparação entre o estágio declarado na Q10 e o inferido pelas respostas</a:t>
             </a:r>
             <a:endParaRPr lang="en-US" sz="1200" dirty="0"/>
           </a:p>
@@ -6102,11 +6102,11 @@
             <a:avLst/>
           </a:prstGeom>
           <a:solidFill>
-            <a:srgbClr val="52B788"/>
+            <a:srgbClr val="2D6A4F"/>
           </a:solidFill>
           <a:ln w="12700">
             <a:solidFill>
-              <a:srgbClr val="52B788"/>
+              <a:srgbClr val="2D6A4F"/>
             </a:solidFill>
             <a:prstDash val="solid"/>
           </a:ln>
@@ -6139,7 +6139,7 @@
             <a:r>
               <a:rPr lang="en-US" sz="3200" b="1" dirty="0">
                 <a:solidFill>
-                  <a:srgbClr val="52B788"/>
+                  <a:srgbClr val="2D6A4F"/>
                 </a:solidFill>
                 <a:latin typeface="Cambria" pitchFamily="34" charset="0"/>
                 <a:ea typeface="Cambria" pitchFamily="34" charset="-122"/>
@@ -6178,11 +6178,11 @@
             <a:r>
               <a:rPr lang="en-US" sz="1000" dirty="0">
                 <a:solidFill>
-                  <a:srgbClr val="748C78"/>
-                </a:solidFill>
-                <a:latin typeface="Calibri" pitchFamily="34" charset="0"/>
-                <a:ea typeface="Calibri" pitchFamily="34" charset="-122"/>
-                <a:cs typeface="Calibri" pitchFamily="34" charset="-120"/>
+                  <a:srgbClr val="8A7070"/>
+                </a:solidFill>
+                <a:latin typeface="Arial" pitchFamily="34" charset="0"/>
+                <a:ea typeface="Arial" pitchFamily="34" charset="-122"/>
+                <a:cs typeface="Arial" pitchFamily="34" charset="-120"/>
               </a:rPr>
               <a:t>Alinhado</a:t>
             </a:r>
@@ -6195,13 +6195,13 @@
             <a:r>
               <a:rPr lang="en-US" sz="1000" dirty="0">
                 <a:solidFill>
-                  <a:srgbClr val="748C78"/>
-                </a:solidFill>
-                <a:latin typeface="Calibri" pitchFamily="34" charset="0"/>
-                <a:ea typeface="Calibri" pitchFamily="34" charset="-122"/>
-                <a:cs typeface="Calibri" pitchFamily="34" charset="-120"/>
-              </a:rPr>
-              <a:t>(37 pessoas)</a:t>
+                  <a:srgbClr val="8A7070"/>
+                </a:solidFill>
+                <a:latin typeface="Arial" pitchFamily="34" charset="0"/>
+                <a:ea typeface="Arial" pitchFamily="34" charset="-122"/>
+                <a:cs typeface="Arial" pitchFamily="34" charset="-120"/>
+              </a:rPr>
+              <a:t>(38 pessoas)</a:t>
             </a:r>
             <a:endParaRPr lang="en-US" sz="1000" dirty="0"/>
           </a:p>
@@ -6222,11 +6222,11 @@
             <a:avLst/>
           </a:prstGeom>
           <a:solidFill>
-            <a:srgbClr val="3B82C4"/>
+            <a:srgbClr val="457B9D"/>
           </a:solidFill>
           <a:ln w="12700">
             <a:solidFill>
-              <a:srgbClr val="3B82C4"/>
+              <a:srgbClr val="457B9D"/>
             </a:solidFill>
             <a:prstDash val="solid"/>
           </a:ln>
@@ -6259,7 +6259,7 @@
             <a:r>
               <a:rPr lang="en-US" sz="3200" b="1" dirty="0">
                 <a:solidFill>
-                  <a:srgbClr val="3B82C4"/>
+                  <a:srgbClr val="457B9D"/>
                 </a:solidFill>
                 <a:latin typeface="Cambria" pitchFamily="34" charset="0"/>
                 <a:ea typeface="Cambria" pitchFamily="34" charset="-122"/>
@@ -6298,11 +6298,11 @@
             <a:r>
               <a:rPr lang="en-US" sz="1000" dirty="0">
                 <a:solidFill>
-                  <a:srgbClr val="748C78"/>
-                </a:solidFill>
-                <a:latin typeface="Calibri" pitchFamily="34" charset="0"/>
-                <a:ea typeface="Calibri" pitchFamily="34" charset="-122"/>
-                <a:cs typeface="Calibri" pitchFamily="34" charset="-120"/>
+                  <a:srgbClr val="8A7070"/>
+                </a:solidFill>
+                <a:latin typeface="Arial" pitchFamily="34" charset="0"/>
+                <a:ea typeface="Arial" pitchFamily="34" charset="-122"/>
+                <a:cs typeface="Arial" pitchFamily="34" charset="-120"/>
               </a:rPr>
               <a:t>Potencial não declarado</a:t>
             </a:r>
@@ -6315,11 +6315,11 @@
             <a:r>
               <a:rPr lang="en-US" sz="1000" dirty="0">
                 <a:solidFill>
-                  <a:srgbClr val="748C78"/>
-                </a:solidFill>
-                <a:latin typeface="Calibri" pitchFamily="34" charset="0"/>
-                <a:ea typeface="Calibri" pitchFamily="34" charset="-122"/>
-                <a:cs typeface="Calibri" pitchFamily="34" charset="-120"/>
+                  <a:srgbClr val="8A7070"/>
+                </a:solidFill>
+                <a:latin typeface="Arial" pitchFamily="34" charset="0"/>
+                <a:ea typeface="Arial" pitchFamily="34" charset="-122"/>
+                <a:cs typeface="Arial" pitchFamily="34" charset="-120"/>
               </a:rPr>
               <a:t>(sub-valorização)</a:t>
             </a:r>
@@ -6342,11 +6342,11 @@
             <a:avLst/>
           </a:prstGeom>
           <a:solidFill>
-            <a:srgbClr val="D4821A"/>
+            <a:srgbClr val="A83048"/>
           </a:solidFill>
           <a:ln w="12700">
             <a:solidFill>
-              <a:srgbClr val="D4821A"/>
+              <a:srgbClr val="A83048"/>
             </a:solidFill>
             <a:prstDash val="solid"/>
           </a:ln>
@@ -6379,7 +6379,7 @@
             <a:r>
               <a:rPr lang="en-US" sz="3200" b="1" dirty="0">
                 <a:solidFill>
-                  <a:srgbClr val="D4821A"/>
+                  <a:srgbClr val="A83048"/>
                 </a:solidFill>
                 <a:latin typeface="Cambria" pitchFamily="34" charset="0"/>
                 <a:ea typeface="Cambria" pitchFamily="34" charset="-122"/>
@@ -6418,11 +6418,11 @@
             <a:r>
               <a:rPr lang="en-US" sz="1000" dirty="0">
                 <a:solidFill>
-                  <a:srgbClr val="748C78"/>
-                </a:solidFill>
-                <a:latin typeface="Calibri" pitchFamily="34" charset="0"/>
-                <a:ea typeface="Calibri" pitchFamily="34" charset="-122"/>
-                <a:cs typeface="Calibri" pitchFamily="34" charset="-120"/>
+                  <a:srgbClr val="8A7070"/>
+                </a:solidFill>
+                <a:latin typeface="Arial" pitchFamily="34" charset="0"/>
+                <a:ea typeface="Arial" pitchFamily="34" charset="-122"/>
+                <a:cs typeface="Arial" pitchFamily="34" charset="-120"/>
               </a:rPr>
               <a:t>Autoposicionamento</a:t>
             </a:r>
@@ -6435,11 +6435,11 @@
             <a:r>
               <a:rPr lang="en-US" sz="1000" dirty="0">
                 <a:solidFill>
-                  <a:srgbClr val="748C78"/>
-                </a:solidFill>
-                <a:latin typeface="Calibri" pitchFamily="34" charset="0"/>
-                <a:ea typeface="Calibri" pitchFamily="34" charset="-122"/>
-                <a:cs typeface="Calibri" pitchFamily="34" charset="-120"/>
+                  <a:srgbClr val="8A7070"/>
+                </a:solidFill>
+                <a:latin typeface="Arial" pitchFamily="34" charset="0"/>
+                <a:ea typeface="Arial" pitchFamily="34" charset="-122"/>
+                <a:cs typeface="Arial" pitchFamily="34" charset="-120"/>
               </a:rPr>
               <a:t>superior</a:t>
             </a:r>
@@ -6477,7 +6477,7 @@
     <p:bg>
       <p:bgPr>
         <a:solidFill>
-          <a:srgbClr val="1B4332"/>
+          <a:srgbClr val="5C1528"/>
         </a:solidFill>
       </p:bgPr>
     </p:bg>
@@ -6516,7 +6516,7 @@
           <a:bodyPr wrap="square" rtlCol="0" anchor="ctr"/>
           <a:lstStyle/>
           <a:p>
-            <a:pPr algn="l" indent="0" marL="0">
+            <a:pPr indent="0" marL="0">
               <a:buNone/>
             </a:pPr>
             <a:r>
@@ -6555,7 +6555,7 @@
           <a:bodyPr wrap="square" rtlCol="0" anchor="ctr"/>
           <a:lstStyle/>
           <a:p>
-            <a:pPr algn="l" indent="0" marL="0">
+            <a:pPr indent="0" marL="0">
               <a:buNone/>
             </a:pPr>
             <a:r>
@@ -6563,9 +6563,9 @@
                 <a:solidFill>
                   <a:srgbClr val="D4821A"/>
                 </a:solidFill>
-                <a:latin typeface="Calibri" pitchFamily="34" charset="0"/>
-                <a:ea typeface="Calibri" pitchFamily="34" charset="-122"/>
-                <a:cs typeface="Calibri" pitchFamily="34" charset="-120"/>
+                <a:latin typeface="Arial" pitchFamily="34" charset="0"/>
+                <a:ea typeface="Arial" pitchFamily="34" charset="-122"/>
+                <a:cs typeface="Arial" pitchFamily="34" charset="-120"/>
               </a:rPr>
               <a:t>e Oportunidades para a Comunidade Arandu</a:t>
             </a:r>
@@ -6588,11 +6588,11 @@
             <a:avLst/>
           </a:prstGeom>
           <a:solidFill>
-            <a:srgbClr val="2D6A4F"/>
+            <a:srgbClr val="7B2230"/>
           </a:solidFill>
           <a:ln w="12700">
             <a:solidFill>
-              <a:srgbClr val="2D6A4F"/>
+              <a:srgbClr val="7B2230"/>
             </a:solidFill>
             <a:prstDash val="solid"/>
           </a:ln>
@@ -6625,7 +6625,7 @@
             <a:r>
               <a:rPr lang="en-US" sz="1800" b="1" dirty="0">
                 <a:solidFill>
-                  <a:srgbClr val="F4A828"/>
+                  <a:srgbClr val="F4C060"/>
                 </a:solidFill>
                 <a:latin typeface="Cambria" pitchFamily="34" charset="0"/>
                 <a:ea typeface="Cambria" pitchFamily="34" charset="-122"/>
@@ -6666,9 +6666,9 @@
                 <a:solidFill>
                   <a:srgbClr val="FFFFFF"/>
                 </a:solidFill>
-                <a:latin typeface="Calibri" pitchFamily="34" charset="0"/>
-                <a:ea typeface="Calibri" pitchFamily="34" charset="-122"/>
-                <a:cs typeface="Calibri" pitchFamily="34" charset="-120"/>
+                <a:latin typeface="Arial" pitchFamily="34" charset="0"/>
+                <a:ea typeface="Arial" pitchFamily="34" charset="-122"/>
+                <a:cs typeface="Arial" pitchFamily="34" charset="-120"/>
               </a:rPr>
               <a:t>Comunidade madura e escolarizada — mas com forte renovação</a:t>
             </a:r>
@@ -6703,13 +6703,13 @@
             <a:r>
               <a:rPr lang="en-US" sz="1050" dirty="0">
                 <a:solidFill>
-                  <a:srgbClr val="B7E4C7"/>
-                </a:solidFill>
-                <a:latin typeface="Calibri" pitchFamily="34" charset="0"/>
-                <a:ea typeface="Calibri" pitchFamily="34" charset="-122"/>
-                <a:cs typeface="Calibri" pitchFamily="34" charset="-120"/>
-              </a:rPr>
-              <a:t>89% com ensino superior, 43 anos em média — e 27% entraram em 2025. Contexto fértil para aprofundamento, mas que exige acolhimento dos novos.</a:t>
+                  <a:srgbClr val="E8D5D0"/>
+                </a:solidFill>
+                <a:latin typeface="Arial" pitchFamily="34" charset="0"/>
+                <a:ea typeface="Arial" pitchFamily="34" charset="-122"/>
+                <a:cs typeface="Arial" pitchFamily="34" charset="-120"/>
+              </a:rPr>
+              <a:t>89% com ensino superior, 43 anos em média — e 27% entraram em 2025. Contexto fértil para aprofundamento, exige acolhimento dos novos.</a:t>
             </a:r>
             <a:endParaRPr lang="en-US" sz="1050" dirty="0"/>
           </a:p>
@@ -6730,11 +6730,11 @@
             <a:avLst/>
           </a:prstGeom>
           <a:solidFill>
-            <a:srgbClr val="2D6A4F"/>
+            <a:srgbClr val="7B2230"/>
           </a:solidFill>
           <a:ln w="12700">
             <a:solidFill>
-              <a:srgbClr val="2D6A4F"/>
+              <a:srgbClr val="7B2230"/>
             </a:solidFill>
             <a:prstDash val="solid"/>
           </a:ln>
@@ -6767,7 +6767,7 @@
             <a:r>
               <a:rPr lang="en-US" sz="1800" b="1" dirty="0">
                 <a:solidFill>
-                  <a:srgbClr val="F4A828"/>
+                  <a:srgbClr val="F4C060"/>
                 </a:solidFill>
                 <a:latin typeface="Cambria" pitchFamily="34" charset="0"/>
                 <a:ea typeface="Cambria" pitchFamily="34" charset="-122"/>
@@ -6808,9 +6808,9 @@
                 <a:solidFill>
                   <a:srgbClr val="FFFFFF"/>
                 </a:solidFill>
-                <a:latin typeface="Calibri" pitchFamily="34" charset="0"/>
-                <a:ea typeface="Calibri" pitchFamily="34" charset="-122"/>
-                <a:cs typeface="Calibri" pitchFamily="34" charset="-120"/>
+                <a:latin typeface="Arial" pitchFamily="34" charset="0"/>
+                <a:ea typeface="Arial" pitchFamily="34" charset="-122"/>
+                <a:cs typeface="Arial" pitchFamily="34" charset="-120"/>
               </a:rPr>
               <a:t>A maioria (44,8%) disse SIM — mas sem papel ativo</a:t>
             </a:r>
@@ -6845,13 +6845,13 @@
             <a:r>
               <a:rPr lang="en-US" sz="1050" dirty="0">
                 <a:solidFill>
-                  <a:srgbClr val="B7E4C7"/>
-                </a:solidFill>
-                <a:latin typeface="Calibri" pitchFamily="34" charset="0"/>
-                <a:ea typeface="Calibri" pitchFamily="34" charset="-122"/>
-                <a:cs typeface="Calibri" pitchFamily="34" charset="-120"/>
-              </a:rPr>
-              <a:t>64 Comprometidos: posicionados no coração da escola, mas com baixíssimo engajamento concreto (5% ativos). Oportunidade: ativar quem já comprometeu.</a:t>
+                  <a:srgbClr val="E8D5D0"/>
+                </a:solidFill>
+                <a:latin typeface="Arial" pitchFamily="34" charset="0"/>
+                <a:ea typeface="Arial" pitchFamily="34" charset="-122"/>
+                <a:cs typeface="Arial" pitchFamily="34" charset="-120"/>
+              </a:rPr>
+              <a:t>64 Comprometidos com baixíssimo engajamento concreto (5% ativos). Oportunidade: ativar quem já comprometeu.</a:t>
             </a:r>
             <a:endParaRPr lang="en-US" sz="1050" dirty="0"/>
           </a:p>
@@ -6872,11 +6872,11 @@
             <a:avLst/>
           </a:prstGeom>
           <a:solidFill>
-            <a:srgbClr val="2D6A4F"/>
+            <a:srgbClr val="7B2230"/>
           </a:solidFill>
           <a:ln w="12700">
             <a:solidFill>
-              <a:srgbClr val="2D6A4F"/>
+              <a:srgbClr val="7B2230"/>
             </a:solidFill>
             <a:prstDash val="solid"/>
           </a:ln>
@@ -6909,7 +6909,7 @@
             <a:r>
               <a:rPr lang="en-US" sz="1800" b="1" dirty="0">
                 <a:solidFill>
-                  <a:srgbClr val="F4A828"/>
+                  <a:srgbClr val="F4C060"/>
                 </a:solidFill>
                 <a:latin typeface="Cambria" pitchFamily="34" charset="0"/>
                 <a:ea typeface="Cambria" pitchFamily="34" charset="-122"/>
@@ -6950,9 +6950,9 @@
                 <a:solidFill>
                   <a:srgbClr val="FFFFFF"/>
                 </a:solidFill>
-                <a:latin typeface="Calibri" pitchFamily="34" charset="0"/>
-                <a:ea typeface="Calibri" pitchFamily="34" charset="-122"/>
-                <a:cs typeface="Calibri" pitchFamily="34" charset="-120"/>
+                <a:latin typeface="Arial" pitchFamily="34" charset="0"/>
+                <a:ea typeface="Arial" pitchFamily="34" charset="-122"/>
+                <a:cs typeface="Arial" pitchFamily="34" charset="-120"/>
               </a:rPr>
               <a:t>32% no ponto de virada — decidir SIM ou sair</a:t>
             </a:r>
@@ -6987,13 +6987,13 @@
             <a:r>
               <a:rPr lang="en-US" sz="1050" dirty="0">
                 <a:solidFill>
-                  <a:srgbClr val="B7E4C7"/>
-                </a:solidFill>
-                <a:latin typeface="Calibri" pitchFamily="34" charset="0"/>
-                <a:ea typeface="Calibri" pitchFamily="34" charset="-122"/>
-                <a:cs typeface="Calibri" pitchFamily="34" charset="-120"/>
-              </a:rPr>
-              <a:t>46 pessoas em Inserindo. Precisam ser acompanhadas. Entre os que entraram em 2025 (38), muitos têm alta concordância — potencial de conversão rápida.</a:t>
+                  <a:srgbClr val="E8D5D0"/>
+                </a:solidFill>
+                <a:latin typeface="Arial" pitchFamily="34" charset="0"/>
+                <a:ea typeface="Arial" pitchFamily="34" charset="-122"/>
+                <a:cs typeface="Arial" pitchFamily="34" charset="-120"/>
+              </a:rPr>
+              <a:t>46 pessoas em Inserindo, muitas com alta concordância (2025). Potencial de conversão rápida se bem acompanhadas.</a:t>
             </a:r>
             <a:endParaRPr lang="en-US" sz="1050" dirty="0"/>
           </a:p>
@@ -7014,11 +7014,11 @@
             <a:avLst/>
           </a:prstGeom>
           <a:solidFill>
-            <a:srgbClr val="2D6A4F"/>
+            <a:srgbClr val="7B2230"/>
           </a:solidFill>
           <a:ln w="12700">
             <a:solidFill>
-              <a:srgbClr val="2D6A4F"/>
+              <a:srgbClr val="7B2230"/>
             </a:solidFill>
             <a:prstDash val="solid"/>
           </a:ln>
@@ -7051,7 +7051,7 @@
             <a:r>
               <a:rPr lang="en-US" sz="1800" b="1" dirty="0">
                 <a:solidFill>
-                  <a:srgbClr val="F4A828"/>
+                  <a:srgbClr val="F4C060"/>
                 </a:solidFill>
                 <a:latin typeface="Cambria" pitchFamily="34" charset="0"/>
                 <a:ea typeface="Cambria" pitchFamily="34" charset="-122"/>
@@ -7092,9 +7092,9 @@
                 <a:solidFill>
                   <a:srgbClr val="FFFFFF"/>
                 </a:solidFill>
-                <a:latin typeface="Calibri" pitchFamily="34" charset="0"/>
-                <a:ea typeface="Calibri" pitchFamily="34" charset="-122"/>
-                <a:cs typeface="Calibri" pitchFamily="34" charset="-120"/>
+                <a:latin typeface="Arial" pitchFamily="34" charset="0"/>
+                <a:ea typeface="Arial" pitchFamily="34" charset="-122"/>
+                <a:cs typeface="Arial" pitchFamily="34" charset="-120"/>
               </a:rPr>
               <a:t>42% têm mais engajamento real do que declaram</a:t>
             </a:r>
@@ -7129,13 +7129,13 @@
             <a:r>
               <a:rPr lang="en-US" sz="1050" dirty="0">
                 <a:solidFill>
-                  <a:srgbClr val="B7E4C7"/>
-                </a:solidFill>
-                <a:latin typeface="Calibri" pitchFamily="34" charset="0"/>
-                <a:ea typeface="Calibri" pitchFamily="34" charset="-122"/>
-                <a:cs typeface="Calibri" pitchFamily="34" charset="-120"/>
-              </a:rPr>
-              <a:t>Subvalorização sistemática: as respostas revelam pertencimento e acordos acima do autoposicionamento. Oportunidade de reconhecimento e convite.</a:t>
+                  <a:srgbClr val="E8D5D0"/>
+                </a:solidFill>
+                <a:latin typeface="Arial" pitchFamily="34" charset="0"/>
+                <a:ea typeface="Arial" pitchFamily="34" charset="-122"/>
+                <a:cs typeface="Arial" pitchFamily="34" charset="-120"/>
+              </a:rPr>
+              <a:t>Sub-valorização sistemática: as respostas revelam pertencimento e acordos acima do autoposicionamento — oportunidade de reconhecimento.</a:t>
             </a:r>
             <a:endParaRPr lang="en-US" sz="1050" dirty="0"/>
           </a:p>
@@ -7162,17 +7162,17 @@
           <a:bodyPr wrap="square" rtlCol="0" anchor="ctr"/>
           <a:lstStyle/>
           <a:p>
-            <a:pPr algn="l" indent="0" marL="0">
+            <a:pPr indent="0" marL="0">
               <a:buNone/>
             </a:pPr>
             <a:r>
               <a:rPr lang="en-US" sz="1000" dirty="0">
                 <a:solidFill>
-                  <a:srgbClr val="2D6A4F"/>
-                </a:solidFill>
-                <a:latin typeface="Calibri" pitchFamily="34" charset="0"/>
-                <a:ea typeface="Calibri" pitchFamily="34" charset="-122"/>
-                <a:cs typeface="Calibri" pitchFamily="34" charset="-120"/>
+                  <a:srgbClr val="A83048"/>
+                </a:solidFill>
+                <a:latin typeface="Arial" pitchFamily="34" charset="0"/>
+                <a:ea typeface="Arial" pitchFamily="34" charset="-122"/>
+                <a:cs typeface="Arial" pitchFamily="34" charset="-120"/>
               </a:rPr>
               <a:t>Escola Arandu — Pesquisa Comunitária 2025</a:t>
             </a:r>
@@ -7239,7 +7239,7 @@
             <a:r>
               <a:rPr lang="en-US" sz="2600" b="1" dirty="0">
                 <a:solidFill>
-                  <a:srgbClr val="1B4332"/>
+                  <a:srgbClr val="7B2230"/>
                 </a:solidFill>
                 <a:latin typeface="Cambria" pitchFamily="34" charset="0"/>
                 <a:ea typeface="Cambria" pitchFamily="34" charset="-122"/>
@@ -7278,11 +7278,11 @@
             <a:r>
               <a:rPr lang="en-US" sz="1200" i="1" dirty="0">
                 <a:solidFill>
-                  <a:srgbClr val="748C78"/>
-                </a:solidFill>
-                <a:latin typeface="Calibri" pitchFamily="34" charset="0"/>
-                <a:ea typeface="Calibri" pitchFamily="34" charset="-122"/>
-                <a:cs typeface="Calibri" pitchFamily="34" charset="-120"/>
+                  <a:srgbClr val="8A7070"/>
+                </a:solidFill>
+                <a:latin typeface="Arial" pitchFamily="34" charset="0"/>
+                <a:ea typeface="Arial" pitchFamily="34" charset="-122"/>
+                <a:cs typeface="Arial" pitchFamily="34" charset="-120"/>
               </a:rPr>
               <a:t>Contexto, objetivo e estrutura do instrumento de coleta</a:t>
             </a:r>
@@ -7305,11 +7305,11 @@
             <a:avLst/>
           </a:prstGeom>
           <a:solidFill>
-            <a:srgbClr val="F4FAF7"/>
+            <a:srgbClr val="FDF6F4"/>
           </a:solidFill>
           <a:ln w="12700">
             <a:solidFill>
-              <a:srgbClr val="B7E4C7"/>
+              <a:srgbClr val="E8D5D0"/>
             </a:solidFill>
             <a:prstDash val="solid"/>
           </a:ln>
@@ -7342,7 +7342,7 @@
             <a:r>
               <a:rPr lang="en-US" sz="1200" b="1" dirty="0">
                 <a:solidFill>
-                  <a:srgbClr val="2D6A4F"/>
+                  <a:srgbClr val="7B2230"/>
                 </a:solidFill>
                 <a:latin typeface="Cambria" pitchFamily="34" charset="0"/>
                 <a:ea typeface="Cambria" pitchFamily="34" charset="-122"/>
@@ -7381,13 +7381,13 @@
             <a:r>
               <a:rPr lang="en-US" sz="1100" dirty="0">
                 <a:solidFill>
-                  <a:srgbClr val="1B2B1E"/>
-                </a:solidFill>
-                <a:latin typeface="Calibri" pitchFamily="34" charset="0"/>
-                <a:ea typeface="Calibri" pitchFamily="34" charset="-122"/>
-                <a:cs typeface="Calibri" pitchFamily="34" charset="-120"/>
-              </a:rPr>
-              <a:t>Compreender a realidade socioeconômica das famílias da Arandu e o nível de engajamento de cada membro com os princípios e processos da escola.</a:t>
+                  <a:srgbClr val="1B2420"/>
+                </a:solidFill>
+                <a:latin typeface="Arial" pitchFamily="34" charset="0"/>
+                <a:ea typeface="Arial" pitchFamily="34" charset="-122"/>
+                <a:cs typeface="Arial" pitchFamily="34" charset="-120"/>
+              </a:rPr>
+              <a:t>Compreender a realidade socioeconômica das famílias e o engajamento de cada membro com os princípios e processos da Arandu.</a:t>
             </a:r>
             <a:endParaRPr lang="en-US" sz="1100" dirty="0"/>
           </a:p>
@@ -7420,7 +7420,7 @@
             <a:r>
               <a:rPr lang="en-US" sz="1200" b="1" dirty="0">
                 <a:solidFill>
-                  <a:srgbClr val="2D6A4F"/>
+                  <a:srgbClr val="7B2230"/>
                 </a:solidFill>
                 <a:latin typeface="Cambria" pitchFamily="34" charset="0"/>
                 <a:ea typeface="Cambria" pitchFamily="34" charset="-122"/>
@@ -7459,11 +7459,11 @@
             <a:r>
               <a:rPr lang="en-US" sz="1100" dirty="0">
                 <a:solidFill>
-                  <a:srgbClr val="1B2B1E"/>
-                </a:solidFill>
-                <a:latin typeface="Calibri" pitchFamily="34" charset="0"/>
-                <a:ea typeface="Calibri" pitchFamily="34" charset="-122"/>
-                <a:cs typeface="Calibri" pitchFamily="34" charset="-120"/>
+                  <a:srgbClr val="1B2420"/>
+                </a:solidFill>
+                <a:latin typeface="Arial" pitchFamily="34" charset="0"/>
+                <a:ea typeface="Arial" pitchFamily="34" charset="-122"/>
+                <a:cs typeface="Arial" pitchFamily="34" charset="-120"/>
               </a:rPr>
               <a:t>Questionário online estruturado, enviado via Google Forms a todas as famílias em setembro de 2025.</a:t>
             </a:r>
@@ -7498,7 +7498,7 @@
             <a:r>
               <a:rPr lang="en-US" sz="1200" b="1" dirty="0">
                 <a:solidFill>
-                  <a:srgbClr val="2D6A4F"/>
+                  <a:srgbClr val="7B2230"/>
                 </a:solidFill>
                 <a:latin typeface="Cambria" pitchFamily="34" charset="0"/>
                 <a:ea typeface="Cambria" pitchFamily="34" charset="-122"/>
@@ -7537,13 +7537,13 @@
             <a:r>
               <a:rPr lang="en-US" sz="1100" dirty="0">
                 <a:solidFill>
-                  <a:srgbClr val="1B2B1E"/>
-                </a:solidFill>
-                <a:latin typeface="Calibri" pitchFamily="34" charset="0"/>
-                <a:ea typeface="Calibri" pitchFamily="34" charset="-122"/>
-                <a:cs typeface="Calibri" pitchFamily="34" charset="-120"/>
-              </a:rPr>
-              <a:t>143 adultos participaram — entre pais/mães de alunos e colaboradores da escola.</a:t>
+                  <a:srgbClr val="1B2420"/>
+                </a:solidFill>
+                <a:latin typeface="Arial" pitchFamily="34" charset="0"/>
+                <a:ea typeface="Arial" pitchFamily="34" charset="-122"/>
+                <a:cs typeface="Arial" pitchFamily="34" charset="-120"/>
+              </a:rPr>
+              <a:t>143 adultos participaram — entre mães/pais de alunos e colaboradores da escola.</a:t>
             </a:r>
             <a:endParaRPr lang="en-US" sz="1100" dirty="0"/>
           </a:p>
@@ -7576,7 +7576,7 @@
             <a:r>
               <a:rPr lang="en-US" sz="1200" b="1" dirty="0">
                 <a:solidFill>
-                  <a:srgbClr val="2D6A4F"/>
+                  <a:srgbClr val="7B2230"/>
                 </a:solidFill>
                 <a:latin typeface="Cambria" pitchFamily="34" charset="0"/>
                 <a:ea typeface="Cambria" pitchFamily="34" charset="-122"/>
@@ -7615,13 +7615,13 @@
             <a:r>
               <a:rPr lang="en-US" sz="1100" dirty="0">
                 <a:solidFill>
-                  <a:srgbClr val="1B2B1E"/>
-                </a:solidFill>
-                <a:latin typeface="Calibri" pitchFamily="34" charset="0"/>
-                <a:ea typeface="Calibri" pitchFamily="34" charset="-122"/>
-                <a:cs typeface="Calibri" pitchFamily="34" charset="-120"/>
-              </a:rPr>
-              <a:t>4 blocos: Perfil Demográfico, Perfil Familiar, Perfil Econômico e Vínculo com a Escola — seguidos de perguntas sobre os 7 Processos Sociais.</a:t>
+                  <a:srgbClr val="1B2420"/>
+                </a:solidFill>
+                <a:latin typeface="Arial" pitchFamily="34" charset="0"/>
+                <a:ea typeface="Arial" pitchFamily="34" charset="-122"/>
+                <a:cs typeface="Arial" pitchFamily="34" charset="-120"/>
+              </a:rPr>
+              <a:t>4 blocos: Perfil Demográfico, Perfil Familiar, Perfil Econômico e Vínculo com a Escola — seguidos das questões sobre os 7 Processos Sociais.</a:t>
             </a:r>
             <a:endParaRPr lang="en-US" sz="1100" dirty="0"/>
           </a:p>
@@ -7636,6 +7636,249 @@
         <p:spPr>
           <a:xfrm>
             <a:off x="5577840" y="1097280"/>
+            <a:ext cx="1325880" cy="1554480"/>
+          </a:xfrm>
+          <a:prstGeom prst="rect">
+            <a:avLst/>
+          </a:prstGeom>
+          <a:solidFill>
+            <a:srgbClr val="7B2230"/>
+          </a:solidFill>
+          <a:ln w="12700">
+            <a:solidFill>
+              <a:srgbClr val="7B2230"/>
+            </a:solidFill>
+            <a:prstDash val="solid"/>
+          </a:ln>
+        </p:spPr>
+      </p:sp>
+      <p:sp>
+        <p:nvSpPr>
+          <p:cNvPr id="14" name="Text 12"/>
+          <p:cNvSpPr/>
+          <p:nvPr/>
+        </p:nvSpPr>
+        <p:spPr>
+          <a:xfrm>
+            <a:off x="5577840" y="1554480"/>
+            <a:ext cx="1325880" cy="822960"/>
+          </a:xfrm>
+          <a:prstGeom prst="rect">
+            <a:avLst/>
+          </a:prstGeom>
+          <a:noFill/>
+          <a:ln/>
+        </p:spPr>
+        <p:txBody>
+          <a:bodyPr wrap="square" lIns="0" tIns="0" rIns="0" bIns="0" rtlCol="0" anchor="ctr"/>
+          <a:lstStyle/>
+          <a:p>
+            <a:pPr algn="ctr" indent="0" marL="0">
+              <a:buNone/>
+            </a:pPr>
+            <a:r>
+              <a:rPr lang="en-US" sz="1200" b="1" dirty="0">
+                <a:solidFill>
+                  <a:srgbClr val="FFFFFF"/>
+                </a:solidFill>
+                <a:latin typeface="Arial" pitchFamily="34" charset="0"/>
+                <a:ea typeface="Arial" pitchFamily="34" charset="-122"/>
+                <a:cs typeface="Arial" pitchFamily="34" charset="-120"/>
+              </a:rPr>
+              <a:t>Perfil</a:t>
+            </a:r>
+            <a:endParaRPr lang="en-US" sz="1200" dirty="0"/>
+          </a:p>
+          <a:p>
+            <a:pPr algn="ctr" indent="0" marL="0">
+              <a:buNone/>
+            </a:pPr>
+            <a:r>
+              <a:rPr lang="en-US" sz="1200" b="1" dirty="0">
+                <a:solidFill>
+                  <a:srgbClr val="FFFFFF"/>
+                </a:solidFill>
+                <a:latin typeface="Arial" pitchFamily="34" charset="0"/>
+                <a:ea typeface="Arial" pitchFamily="34" charset="-122"/>
+                <a:cs typeface="Arial" pitchFamily="34" charset="-120"/>
+              </a:rPr>
+              <a:t>Demográfico</a:t>
+            </a:r>
+            <a:endParaRPr lang="en-US" sz="1200" dirty="0"/>
+          </a:p>
+        </p:txBody>
+      </p:sp>
+      <p:sp>
+        <p:nvSpPr>
+          <p:cNvPr id="15" name="Shape 13"/>
+          <p:cNvSpPr/>
+          <p:nvPr/>
+        </p:nvSpPr>
+        <p:spPr>
+          <a:xfrm>
+            <a:off x="7040880" y="1097280"/>
+            <a:ext cx="1325880" cy="1554480"/>
+          </a:xfrm>
+          <a:prstGeom prst="rect">
+            <a:avLst/>
+          </a:prstGeom>
+          <a:solidFill>
+            <a:srgbClr val="457B9D"/>
+          </a:solidFill>
+          <a:ln w="12700">
+            <a:solidFill>
+              <a:srgbClr val="457B9D"/>
+            </a:solidFill>
+            <a:prstDash val="solid"/>
+          </a:ln>
+        </p:spPr>
+      </p:sp>
+      <p:sp>
+        <p:nvSpPr>
+          <p:cNvPr id="16" name="Text 14"/>
+          <p:cNvSpPr/>
+          <p:nvPr/>
+        </p:nvSpPr>
+        <p:spPr>
+          <a:xfrm>
+            <a:off x="7040880" y="1554480"/>
+            <a:ext cx="1325880" cy="822960"/>
+          </a:xfrm>
+          <a:prstGeom prst="rect">
+            <a:avLst/>
+          </a:prstGeom>
+          <a:noFill/>
+          <a:ln/>
+        </p:spPr>
+        <p:txBody>
+          <a:bodyPr wrap="square" lIns="0" tIns="0" rIns="0" bIns="0" rtlCol="0" anchor="ctr"/>
+          <a:lstStyle/>
+          <a:p>
+            <a:pPr algn="ctr" indent="0" marL="0">
+              <a:buNone/>
+            </a:pPr>
+            <a:r>
+              <a:rPr lang="en-US" sz="1200" b="1" dirty="0">
+                <a:solidFill>
+                  <a:srgbClr val="FFFFFF"/>
+                </a:solidFill>
+                <a:latin typeface="Arial" pitchFamily="34" charset="0"/>
+                <a:ea typeface="Arial" pitchFamily="34" charset="-122"/>
+                <a:cs typeface="Arial" pitchFamily="34" charset="-120"/>
+              </a:rPr>
+              <a:t>Perfil</a:t>
+            </a:r>
+            <a:endParaRPr lang="en-US" sz="1200" dirty="0"/>
+          </a:p>
+          <a:p>
+            <a:pPr algn="ctr" indent="0" marL="0">
+              <a:buNone/>
+            </a:pPr>
+            <a:r>
+              <a:rPr lang="en-US" sz="1200" b="1" dirty="0">
+                <a:solidFill>
+                  <a:srgbClr val="FFFFFF"/>
+                </a:solidFill>
+                <a:latin typeface="Arial" pitchFamily="34" charset="0"/>
+                <a:ea typeface="Arial" pitchFamily="34" charset="-122"/>
+                <a:cs typeface="Arial" pitchFamily="34" charset="-120"/>
+              </a:rPr>
+              <a:t>Familiar</a:t>
+            </a:r>
+            <a:endParaRPr lang="en-US" sz="1200" dirty="0"/>
+          </a:p>
+        </p:txBody>
+      </p:sp>
+      <p:sp>
+        <p:nvSpPr>
+          <p:cNvPr id="17" name="Shape 15"/>
+          <p:cNvSpPr/>
+          <p:nvPr/>
+        </p:nvSpPr>
+        <p:spPr>
+          <a:xfrm>
+            <a:off x="5577840" y="2880360"/>
+            <a:ext cx="1325880" cy="1554480"/>
+          </a:xfrm>
+          <a:prstGeom prst="rect">
+            <a:avLst/>
+          </a:prstGeom>
+          <a:solidFill>
+            <a:srgbClr val="D4821A"/>
+          </a:solidFill>
+          <a:ln w="12700">
+            <a:solidFill>
+              <a:srgbClr val="D4821A"/>
+            </a:solidFill>
+            <a:prstDash val="solid"/>
+          </a:ln>
+        </p:spPr>
+      </p:sp>
+      <p:sp>
+        <p:nvSpPr>
+          <p:cNvPr id="18" name="Text 16"/>
+          <p:cNvSpPr/>
+          <p:nvPr/>
+        </p:nvSpPr>
+        <p:spPr>
+          <a:xfrm>
+            <a:off x="5577840" y="3337560"/>
+            <a:ext cx="1325880" cy="822960"/>
+          </a:xfrm>
+          <a:prstGeom prst="rect">
+            <a:avLst/>
+          </a:prstGeom>
+          <a:noFill/>
+          <a:ln/>
+        </p:spPr>
+        <p:txBody>
+          <a:bodyPr wrap="square" lIns="0" tIns="0" rIns="0" bIns="0" rtlCol="0" anchor="ctr"/>
+          <a:lstStyle/>
+          <a:p>
+            <a:pPr algn="ctr" indent="0" marL="0">
+              <a:buNone/>
+            </a:pPr>
+            <a:r>
+              <a:rPr lang="en-US" sz="1200" b="1" dirty="0">
+                <a:solidFill>
+                  <a:srgbClr val="FFFFFF"/>
+                </a:solidFill>
+                <a:latin typeface="Arial" pitchFamily="34" charset="0"/>
+                <a:ea typeface="Arial" pitchFamily="34" charset="-122"/>
+                <a:cs typeface="Arial" pitchFamily="34" charset="-120"/>
+              </a:rPr>
+              <a:t>Perfil</a:t>
+            </a:r>
+            <a:endParaRPr lang="en-US" sz="1200" dirty="0"/>
+          </a:p>
+          <a:p>
+            <a:pPr algn="ctr" indent="0" marL="0">
+              <a:buNone/>
+            </a:pPr>
+            <a:r>
+              <a:rPr lang="en-US" sz="1200" b="1" dirty="0">
+                <a:solidFill>
+                  <a:srgbClr val="FFFFFF"/>
+                </a:solidFill>
+                <a:latin typeface="Arial" pitchFamily="34" charset="0"/>
+                <a:ea typeface="Arial" pitchFamily="34" charset="-122"/>
+                <a:cs typeface="Arial" pitchFamily="34" charset="-120"/>
+              </a:rPr>
+              <a:t>Econômico</a:t>
+            </a:r>
+            <a:endParaRPr lang="en-US" sz="1200" dirty="0"/>
+          </a:p>
+        </p:txBody>
+      </p:sp>
+      <p:sp>
+        <p:nvSpPr>
+          <p:cNvPr id="19" name="Shape 17"/>
+          <p:cNvSpPr/>
+          <p:nvPr/>
+        </p:nvSpPr>
+        <p:spPr>
+          <a:xfrm>
+            <a:off x="7040880" y="2880360"/>
             <a:ext cx="1325880" cy="1554480"/>
           </a:xfrm>
           <a:prstGeom prst="rect">
@@ -7654,249 +7897,6 @@
       </p:sp>
       <p:sp>
         <p:nvSpPr>
-          <p:cNvPr id="14" name="Text 12"/>
-          <p:cNvSpPr/>
-          <p:nvPr/>
-        </p:nvSpPr>
-        <p:spPr>
-          <a:xfrm>
-            <a:off x="5577840" y="1554480"/>
-            <a:ext cx="1325880" cy="822960"/>
-          </a:xfrm>
-          <a:prstGeom prst="rect">
-            <a:avLst/>
-          </a:prstGeom>
-          <a:noFill/>
-          <a:ln/>
-        </p:spPr>
-        <p:txBody>
-          <a:bodyPr wrap="square" lIns="0" tIns="0" rIns="0" bIns="0" rtlCol="0" anchor="ctr"/>
-          <a:lstStyle/>
-          <a:p>
-            <a:pPr algn="ctr" indent="0" marL="0">
-              <a:buNone/>
-            </a:pPr>
-            <a:r>
-              <a:rPr lang="en-US" sz="1200" b="1" dirty="0">
-                <a:solidFill>
-                  <a:srgbClr val="FFFFFF"/>
-                </a:solidFill>
-                <a:latin typeface="Calibri" pitchFamily="34" charset="0"/>
-                <a:ea typeface="Calibri" pitchFamily="34" charset="-122"/>
-                <a:cs typeface="Calibri" pitchFamily="34" charset="-120"/>
-              </a:rPr>
-              <a:t>Perfil</a:t>
-            </a:r>
-            <a:endParaRPr lang="en-US" sz="1200" dirty="0"/>
-          </a:p>
-          <a:p>
-            <a:pPr algn="ctr" indent="0" marL="0">
-              <a:buNone/>
-            </a:pPr>
-            <a:r>
-              <a:rPr lang="en-US" sz="1200" b="1" dirty="0">
-                <a:solidFill>
-                  <a:srgbClr val="FFFFFF"/>
-                </a:solidFill>
-                <a:latin typeface="Calibri" pitchFamily="34" charset="0"/>
-                <a:ea typeface="Calibri" pitchFamily="34" charset="-122"/>
-                <a:cs typeface="Calibri" pitchFamily="34" charset="-120"/>
-              </a:rPr>
-              <a:t>Demográfico</a:t>
-            </a:r>
-            <a:endParaRPr lang="en-US" sz="1200" dirty="0"/>
-          </a:p>
-        </p:txBody>
-      </p:sp>
-      <p:sp>
-        <p:nvSpPr>
-          <p:cNvPr id="15" name="Shape 13"/>
-          <p:cNvSpPr/>
-          <p:nvPr/>
-        </p:nvSpPr>
-        <p:spPr>
-          <a:xfrm>
-            <a:off x="7040880" y="1097280"/>
-            <a:ext cx="1325880" cy="1554480"/>
-          </a:xfrm>
-          <a:prstGeom prst="rect">
-            <a:avLst/>
-          </a:prstGeom>
-          <a:solidFill>
-            <a:srgbClr val="457B9D"/>
-          </a:solidFill>
-          <a:ln w="12700">
-            <a:solidFill>
-              <a:srgbClr val="457B9D"/>
-            </a:solidFill>
-            <a:prstDash val="solid"/>
-          </a:ln>
-        </p:spPr>
-      </p:sp>
-      <p:sp>
-        <p:nvSpPr>
-          <p:cNvPr id="16" name="Text 14"/>
-          <p:cNvSpPr/>
-          <p:nvPr/>
-        </p:nvSpPr>
-        <p:spPr>
-          <a:xfrm>
-            <a:off x="7040880" y="1554480"/>
-            <a:ext cx="1325880" cy="822960"/>
-          </a:xfrm>
-          <a:prstGeom prst="rect">
-            <a:avLst/>
-          </a:prstGeom>
-          <a:noFill/>
-          <a:ln/>
-        </p:spPr>
-        <p:txBody>
-          <a:bodyPr wrap="square" lIns="0" tIns="0" rIns="0" bIns="0" rtlCol="0" anchor="ctr"/>
-          <a:lstStyle/>
-          <a:p>
-            <a:pPr algn="ctr" indent="0" marL="0">
-              <a:buNone/>
-            </a:pPr>
-            <a:r>
-              <a:rPr lang="en-US" sz="1200" b="1" dirty="0">
-                <a:solidFill>
-                  <a:srgbClr val="FFFFFF"/>
-                </a:solidFill>
-                <a:latin typeface="Calibri" pitchFamily="34" charset="0"/>
-                <a:ea typeface="Calibri" pitchFamily="34" charset="-122"/>
-                <a:cs typeface="Calibri" pitchFamily="34" charset="-120"/>
-              </a:rPr>
-              <a:t>Perfil</a:t>
-            </a:r>
-            <a:endParaRPr lang="en-US" sz="1200" dirty="0"/>
-          </a:p>
-          <a:p>
-            <a:pPr algn="ctr" indent="0" marL="0">
-              <a:buNone/>
-            </a:pPr>
-            <a:r>
-              <a:rPr lang="en-US" sz="1200" b="1" dirty="0">
-                <a:solidFill>
-                  <a:srgbClr val="FFFFFF"/>
-                </a:solidFill>
-                <a:latin typeface="Calibri" pitchFamily="34" charset="0"/>
-                <a:ea typeface="Calibri" pitchFamily="34" charset="-122"/>
-                <a:cs typeface="Calibri" pitchFamily="34" charset="-120"/>
-              </a:rPr>
-              <a:t>Familiar</a:t>
-            </a:r>
-            <a:endParaRPr lang="en-US" sz="1200" dirty="0"/>
-          </a:p>
-        </p:txBody>
-      </p:sp>
-      <p:sp>
-        <p:nvSpPr>
-          <p:cNvPr id="17" name="Shape 15"/>
-          <p:cNvSpPr/>
-          <p:nvPr/>
-        </p:nvSpPr>
-        <p:spPr>
-          <a:xfrm>
-            <a:off x="5577840" y="2880360"/>
-            <a:ext cx="1325880" cy="1554480"/>
-          </a:xfrm>
-          <a:prstGeom prst="rect">
-            <a:avLst/>
-          </a:prstGeom>
-          <a:solidFill>
-            <a:srgbClr val="D4821A"/>
-          </a:solidFill>
-          <a:ln w="12700">
-            <a:solidFill>
-              <a:srgbClr val="D4821A"/>
-            </a:solidFill>
-            <a:prstDash val="solid"/>
-          </a:ln>
-        </p:spPr>
-      </p:sp>
-      <p:sp>
-        <p:nvSpPr>
-          <p:cNvPr id="18" name="Text 16"/>
-          <p:cNvSpPr/>
-          <p:nvPr/>
-        </p:nvSpPr>
-        <p:spPr>
-          <a:xfrm>
-            <a:off x="5577840" y="3337560"/>
-            <a:ext cx="1325880" cy="822960"/>
-          </a:xfrm>
-          <a:prstGeom prst="rect">
-            <a:avLst/>
-          </a:prstGeom>
-          <a:noFill/>
-          <a:ln/>
-        </p:spPr>
-        <p:txBody>
-          <a:bodyPr wrap="square" lIns="0" tIns="0" rIns="0" bIns="0" rtlCol="0" anchor="ctr"/>
-          <a:lstStyle/>
-          <a:p>
-            <a:pPr algn="ctr" indent="0" marL="0">
-              <a:buNone/>
-            </a:pPr>
-            <a:r>
-              <a:rPr lang="en-US" sz="1200" b="1" dirty="0">
-                <a:solidFill>
-                  <a:srgbClr val="FFFFFF"/>
-                </a:solidFill>
-                <a:latin typeface="Calibri" pitchFamily="34" charset="0"/>
-                <a:ea typeface="Calibri" pitchFamily="34" charset="-122"/>
-                <a:cs typeface="Calibri" pitchFamily="34" charset="-120"/>
-              </a:rPr>
-              <a:t>Perfil</a:t>
-            </a:r>
-            <a:endParaRPr lang="en-US" sz="1200" dirty="0"/>
-          </a:p>
-          <a:p>
-            <a:pPr algn="ctr" indent="0" marL="0">
-              <a:buNone/>
-            </a:pPr>
-            <a:r>
-              <a:rPr lang="en-US" sz="1200" b="1" dirty="0">
-                <a:solidFill>
-                  <a:srgbClr val="FFFFFF"/>
-                </a:solidFill>
-                <a:latin typeface="Calibri" pitchFamily="34" charset="0"/>
-                <a:ea typeface="Calibri" pitchFamily="34" charset="-122"/>
-                <a:cs typeface="Calibri" pitchFamily="34" charset="-120"/>
-              </a:rPr>
-              <a:t>Econômico</a:t>
-            </a:r>
-            <a:endParaRPr lang="en-US" sz="1200" dirty="0"/>
-          </a:p>
-        </p:txBody>
-      </p:sp>
-      <p:sp>
-        <p:nvSpPr>
-          <p:cNvPr id="19" name="Shape 17"/>
-          <p:cNvSpPr/>
-          <p:nvPr/>
-        </p:nvSpPr>
-        <p:spPr>
-          <a:xfrm>
-            <a:off x="7040880" y="2880360"/>
-            <a:ext cx="1325880" cy="1554480"/>
-          </a:xfrm>
-          <a:prstGeom prst="rect">
-            <a:avLst/>
-          </a:prstGeom>
-          <a:solidFill>
-            <a:srgbClr val="6B46C1"/>
-          </a:solidFill>
-          <a:ln w="12700">
-            <a:solidFill>
-              <a:srgbClr val="6B46C1"/>
-            </a:solidFill>
-            <a:prstDash val="solid"/>
-          </a:ln>
-        </p:spPr>
-      </p:sp>
-      <p:sp>
-        <p:nvSpPr>
           <p:cNvPr id="20" name="Text 18"/>
           <p:cNvSpPr/>
           <p:nvPr/>
@@ -7924,9 +7924,9 @@
                 <a:solidFill>
                   <a:srgbClr val="FFFFFF"/>
                 </a:solidFill>
-                <a:latin typeface="Calibri" pitchFamily="34" charset="0"/>
-                <a:ea typeface="Calibri" pitchFamily="34" charset="-122"/>
-                <a:cs typeface="Calibri" pitchFamily="34" charset="-120"/>
+                <a:latin typeface="Arial" pitchFamily="34" charset="0"/>
+                <a:ea typeface="Arial" pitchFamily="34" charset="-122"/>
+                <a:cs typeface="Arial" pitchFamily="34" charset="-120"/>
               </a:rPr>
               <a:t>Vínculo com</a:t>
             </a:r>
@@ -7941,9 +7941,9 @@
                 <a:solidFill>
                   <a:srgbClr val="FFFFFF"/>
                 </a:solidFill>
-                <a:latin typeface="Calibri" pitchFamily="34" charset="0"/>
-                <a:ea typeface="Calibri" pitchFamily="34" charset="-122"/>
-                <a:cs typeface="Calibri" pitchFamily="34" charset="-120"/>
+                <a:latin typeface="Arial" pitchFamily="34" charset="0"/>
+                <a:ea typeface="Arial" pitchFamily="34" charset="-122"/>
+                <a:cs typeface="Arial" pitchFamily="34" charset="-120"/>
               </a:rPr>
               <a:t>a Escola</a:t>
             </a:r>
@@ -7978,7 +7978,7 @@
             <a:r>
               <a:rPr lang="en-US" sz="1300" b="1" dirty="0">
                 <a:solidFill>
-                  <a:srgbClr val="2D6A4F"/>
+                  <a:srgbClr val="7B2230"/>
                 </a:solidFill>
                 <a:latin typeface="Cambria" pitchFamily="34" charset="0"/>
                 <a:ea typeface="Cambria" pitchFamily="34" charset="-122"/>
@@ -7995,7 +7995,7 @@
             <a:r>
               <a:rPr lang="en-US" sz="1300" b="1" dirty="0">
                 <a:solidFill>
-                  <a:srgbClr val="2D6A4F"/>
+                  <a:srgbClr val="7B2230"/>
                 </a:solidFill>
                 <a:latin typeface="Cambria" pitchFamily="34" charset="0"/>
                 <a:ea typeface="Cambria" pitchFamily="34" charset="-122"/>
@@ -8066,7 +8066,7 @@
             <a:r>
               <a:rPr lang="en-US" sz="2600" b="1" dirty="0">
                 <a:solidFill>
-                  <a:srgbClr val="1B4332"/>
+                  <a:srgbClr val="7B2230"/>
                 </a:solidFill>
                 <a:latin typeface="Cambria" pitchFamily="34" charset="0"/>
                 <a:ea typeface="Cambria" pitchFamily="34" charset="-122"/>
@@ -8105,11 +8105,11 @@
             <a:r>
               <a:rPr lang="en-US" sz="1200" i="1" dirty="0">
                 <a:solidFill>
-                  <a:srgbClr val="748C78"/>
-                </a:solidFill>
-                <a:latin typeface="Calibri" pitchFamily="34" charset="0"/>
-                <a:ea typeface="Calibri" pitchFamily="34" charset="-122"/>
-                <a:cs typeface="Calibri" pitchFamily="34" charset="-120"/>
+                  <a:srgbClr val="8A7070"/>
+                </a:solidFill>
+                <a:latin typeface="Arial" pitchFamily="34" charset="0"/>
+                <a:ea typeface="Arial" pitchFamily="34" charset="-122"/>
+                <a:cs typeface="Arial" pitchFamily="34" charset="-120"/>
               </a:rPr>
               <a:t>Gênero, faixa etária e escolaridade dos 143 respondentes</a:t>
             </a:r>
@@ -8144,7 +8144,7 @@
             <a:r>
               <a:rPr lang="en-US" sz="4200" b="1" dirty="0">
                 <a:solidFill>
-                  <a:srgbClr val="2D6A4F"/>
+                  <a:srgbClr val="7B2230"/>
                 </a:solidFill>
                 <a:latin typeface="Cambria" pitchFamily="34" charset="0"/>
                 <a:ea typeface="Cambria" pitchFamily="34" charset="-122"/>
@@ -8165,7 +8165,7 @@
         <p:spPr>
           <a:xfrm>
             <a:off x="457200" y="1737360"/>
-            <a:ext cx="2011680" cy="347472"/>
+            <a:ext cx="2011680" cy="365760"/>
           </a:xfrm>
           <a:prstGeom prst="rect">
             <a:avLst/>
@@ -8183,11 +8183,11 @@
             <a:r>
               <a:rPr lang="en-US" sz="1100" dirty="0">
                 <a:solidFill>
-                  <a:srgbClr val="748C78"/>
-                </a:solidFill>
-                <a:latin typeface="Calibri" pitchFamily="34" charset="0"/>
-                <a:ea typeface="Calibri" pitchFamily="34" charset="-122"/>
-                <a:cs typeface="Calibri" pitchFamily="34" charset="-120"/>
+                  <a:srgbClr val="8A7070"/>
+                </a:solidFill>
+                <a:latin typeface="Arial" pitchFamily="34" charset="0"/>
+                <a:ea typeface="Arial" pitchFamily="34" charset="-122"/>
+                <a:cs typeface="Arial" pitchFamily="34" charset="-120"/>
               </a:rPr>
               <a:t>são mulheres</a:t>
             </a:r>
@@ -8222,7 +8222,7 @@
             <a:r>
               <a:rPr lang="en-US" sz="4200" b="1" dirty="0">
                 <a:solidFill>
-                  <a:srgbClr val="2D6A4F"/>
+                  <a:srgbClr val="7B2230"/>
                 </a:solidFill>
                 <a:latin typeface="Cambria" pitchFamily="34" charset="0"/>
                 <a:ea typeface="Cambria" pitchFamily="34" charset="-122"/>
@@ -8243,7 +8243,7 @@
         <p:spPr>
           <a:xfrm>
             <a:off x="457200" y="2807208"/>
-            <a:ext cx="2011680" cy="347472"/>
+            <a:ext cx="2011680" cy="365760"/>
           </a:xfrm>
           <a:prstGeom prst="rect">
             <a:avLst/>
@@ -8261,11 +8261,11 @@
             <a:r>
               <a:rPr lang="en-US" sz="1100" dirty="0">
                 <a:solidFill>
-                  <a:srgbClr val="748C78"/>
-                </a:solidFill>
-                <a:latin typeface="Calibri" pitchFamily="34" charset="0"/>
-                <a:ea typeface="Calibri" pitchFamily="34" charset="-122"/>
-                <a:cs typeface="Calibri" pitchFamily="34" charset="-120"/>
+                  <a:srgbClr val="8A7070"/>
+                </a:solidFill>
+                <a:latin typeface="Arial" pitchFamily="34" charset="0"/>
+                <a:ea typeface="Arial" pitchFamily="34" charset="-122"/>
+                <a:cs typeface="Arial" pitchFamily="34" charset="-120"/>
               </a:rPr>
               <a:t>anos, idade média</a:t>
             </a:r>
@@ -8300,7 +8300,7 @@
             <a:r>
               <a:rPr lang="en-US" sz="4200" b="1" dirty="0">
                 <a:solidFill>
-                  <a:srgbClr val="2D6A4F"/>
+                  <a:srgbClr val="7B2230"/>
                 </a:solidFill>
                 <a:latin typeface="Cambria" pitchFamily="34" charset="0"/>
                 <a:ea typeface="Cambria" pitchFamily="34" charset="-122"/>
@@ -8321,7 +8321,7 @@
         <p:spPr>
           <a:xfrm>
             <a:off x="457200" y="3886200"/>
-            <a:ext cx="2011680" cy="347472"/>
+            <a:ext cx="2011680" cy="365760"/>
           </a:xfrm>
           <a:prstGeom prst="rect">
             <a:avLst/>
@@ -8339,11 +8339,11 @@
             <a:r>
               <a:rPr lang="en-US" sz="1100" dirty="0">
                 <a:solidFill>
-                  <a:srgbClr val="748C78"/>
-                </a:solidFill>
-                <a:latin typeface="Calibri" pitchFamily="34" charset="0"/>
-                <a:ea typeface="Calibri" pitchFamily="34" charset="-122"/>
-                <a:cs typeface="Calibri" pitchFamily="34" charset="-120"/>
+                  <a:srgbClr val="8A7070"/>
+                </a:solidFill>
+                <a:latin typeface="Arial" pitchFamily="34" charset="0"/>
+                <a:ea typeface="Arial" pitchFamily="34" charset="-122"/>
+                <a:cs typeface="Arial" pitchFamily="34" charset="-120"/>
               </a:rPr>
               <a:t>nível superior</a:t>
             </a:r>
@@ -8356,11 +8356,11 @@
             <a:r>
               <a:rPr lang="en-US" sz="1100" dirty="0">
                 <a:solidFill>
-                  <a:srgbClr val="748C78"/>
-                </a:solidFill>
-                <a:latin typeface="Calibri" pitchFamily="34" charset="0"/>
-                <a:ea typeface="Calibri" pitchFamily="34" charset="-122"/>
-                <a:cs typeface="Calibri" pitchFamily="34" charset="-120"/>
+                  <a:srgbClr val="8A7070"/>
+                </a:solidFill>
+                <a:latin typeface="Arial" pitchFamily="34" charset="0"/>
+                <a:ea typeface="Arial" pitchFamily="34" charset="-122"/>
+                <a:cs typeface="Arial" pitchFamily="34" charset="-120"/>
               </a:rPr>
               <a:t>ou pós-graduação</a:t>
             </a:r>
@@ -8443,7 +8443,7 @@
             <a:r>
               <a:rPr lang="en-US" sz="2600" b="1" dirty="0">
                 <a:solidFill>
-                  <a:srgbClr val="1B4332"/>
+                  <a:srgbClr val="7B2230"/>
                 </a:solidFill>
                 <a:latin typeface="Cambria" pitchFamily="34" charset="0"/>
                 <a:ea typeface="Cambria" pitchFamily="34" charset="-122"/>
@@ -8482,11 +8482,11 @@
             <a:r>
               <a:rPr lang="en-US" sz="1200" i="1" dirty="0">
                 <a:solidFill>
-                  <a:srgbClr val="748C78"/>
-                </a:solidFill>
-                <a:latin typeface="Calibri" pitchFamily="34" charset="0"/>
-                <a:ea typeface="Calibri" pitchFamily="34" charset="-122"/>
-                <a:cs typeface="Calibri" pitchFamily="34" charset="-120"/>
+                  <a:srgbClr val="8A7070"/>
+                </a:solidFill>
+                <a:latin typeface="Arial" pitchFamily="34" charset="0"/>
+                <a:ea typeface="Arial" pitchFamily="34" charset="-122"/>
+                <a:cs typeface="Arial" pitchFamily="34" charset="-120"/>
               </a:rPr>
               <a:t>Composição familiar e distribuição de renda mensal</a:t>
             </a:r>
@@ -8585,7 +8585,7 @@
             <a:r>
               <a:rPr lang="en-US" sz="2600" b="1" dirty="0">
                 <a:solidFill>
-                  <a:srgbClr val="1B4332"/>
+                  <a:srgbClr val="7B2230"/>
                 </a:solidFill>
                 <a:latin typeface="Cambria" pitchFamily="34" charset="0"/>
                 <a:ea typeface="Cambria" pitchFamily="34" charset="-122"/>
@@ -8624,11 +8624,11 @@
             <a:r>
               <a:rPr lang="en-US" sz="1200" i="1" dirty="0">
                 <a:solidFill>
-                  <a:srgbClr val="748C78"/>
-                </a:solidFill>
-                <a:latin typeface="Calibri" pitchFamily="34" charset="0"/>
-                <a:ea typeface="Calibri" pitchFamily="34" charset="-122"/>
-                <a:cs typeface="Calibri" pitchFamily="34" charset="-120"/>
+                  <a:srgbClr val="8A7070"/>
+                </a:solidFill>
+                <a:latin typeface="Arial" pitchFamily="34" charset="0"/>
+                <a:ea typeface="Arial" pitchFamily="34" charset="-122"/>
+                <a:cs typeface="Arial" pitchFamily="34" charset="-120"/>
               </a:rPr>
               <a:t>Tipo de relação, tempo de casa e formação em antroposofia</a:t>
             </a:r>
@@ -8663,7 +8663,7 @@
             <a:r>
               <a:rPr lang="en-US" sz="4200" b="1" dirty="0">
                 <a:solidFill>
-                  <a:srgbClr val="2D6A4F"/>
+                  <a:srgbClr val="7B2230"/>
                 </a:solidFill>
                 <a:latin typeface="Cambria" pitchFamily="34" charset="0"/>
                 <a:ea typeface="Cambria" pitchFamily="34" charset="-122"/>
@@ -8684,7 +8684,7 @@
         <p:spPr>
           <a:xfrm>
             <a:off x="457200" y="1691640"/>
-            <a:ext cx="2377440" cy="347472"/>
+            <a:ext cx="2377440" cy="365760"/>
           </a:xfrm>
           <a:prstGeom prst="rect">
             <a:avLst/>
@@ -8702,11 +8702,11 @@
             <a:r>
               <a:rPr lang="en-US" sz="1100" dirty="0">
                 <a:solidFill>
-                  <a:srgbClr val="748C78"/>
-                </a:solidFill>
-                <a:latin typeface="Calibri" pitchFamily="34" charset="0"/>
-                <a:ea typeface="Calibri" pitchFamily="34" charset="-122"/>
-                <a:cs typeface="Calibri" pitchFamily="34" charset="-120"/>
+                  <a:srgbClr val="8A7070"/>
+                </a:solidFill>
+                <a:latin typeface="Arial" pitchFamily="34" charset="0"/>
+                <a:ea typeface="Arial" pitchFamily="34" charset="-122"/>
+                <a:cs typeface="Arial" pitchFamily="34" charset="-120"/>
               </a:rPr>
               <a:t>mães/pais de aluno(s)</a:t>
             </a:r>
@@ -8762,7 +8762,7 @@
         <p:spPr>
           <a:xfrm>
             <a:off x="3108960" y="1691640"/>
-            <a:ext cx="2377440" cy="347472"/>
+            <a:ext cx="2377440" cy="365760"/>
           </a:xfrm>
           <a:prstGeom prst="rect">
             <a:avLst/>
@@ -8780,11 +8780,11 @@
             <a:r>
               <a:rPr lang="en-US" sz="1100" dirty="0">
                 <a:solidFill>
-                  <a:srgbClr val="748C78"/>
-                </a:solidFill>
-                <a:latin typeface="Calibri" pitchFamily="34" charset="0"/>
-                <a:ea typeface="Calibri" pitchFamily="34" charset="-122"/>
-                <a:cs typeface="Calibri" pitchFamily="34" charset="-120"/>
+                  <a:srgbClr val="8A7070"/>
+                </a:solidFill>
+                <a:latin typeface="Arial" pitchFamily="34" charset="0"/>
+                <a:ea typeface="Arial" pitchFamily="34" charset="-122"/>
+                <a:cs typeface="Arial" pitchFamily="34" charset="-120"/>
               </a:rPr>
               <a:t>entraram em 2025</a:t>
             </a:r>
@@ -8840,7 +8840,7 @@
         <p:spPr>
           <a:xfrm>
             <a:off x="5852160" y="1691640"/>
-            <a:ext cx="2377440" cy="347472"/>
+            <a:ext cx="2377440" cy="365760"/>
           </a:xfrm>
           <a:prstGeom prst="rect">
             <a:avLst/>
@@ -8858,11 +8858,11 @@
             <a:r>
               <a:rPr lang="en-US" sz="1100" dirty="0">
                 <a:solidFill>
-                  <a:srgbClr val="748C78"/>
-                </a:solidFill>
-                <a:latin typeface="Calibri" pitchFamily="34" charset="0"/>
-                <a:ea typeface="Calibri" pitchFamily="34" charset="-122"/>
-                <a:cs typeface="Calibri" pitchFamily="34" charset="-120"/>
+                  <a:srgbClr val="8A7070"/>
+                </a:solidFill>
+                <a:latin typeface="Arial" pitchFamily="34" charset="0"/>
+                <a:ea typeface="Arial" pitchFamily="34" charset="-122"/>
+                <a:cs typeface="Arial" pitchFamily="34" charset="-120"/>
               </a:rPr>
               <a:t>têm formação</a:t>
             </a:r>
@@ -8875,11 +8875,11 @@
             <a:r>
               <a:rPr lang="en-US" sz="1100" dirty="0">
                 <a:solidFill>
-                  <a:srgbClr val="748C78"/>
-                </a:solidFill>
-                <a:latin typeface="Calibri" pitchFamily="34" charset="0"/>
-                <a:ea typeface="Calibri" pitchFamily="34" charset="-122"/>
-                <a:cs typeface="Calibri" pitchFamily="34" charset="-120"/>
+                  <a:srgbClr val="8A7070"/>
+                </a:solidFill>
+                <a:latin typeface="Arial" pitchFamily="34" charset="0"/>
+                <a:ea typeface="Arial" pitchFamily="34" charset="-122"/>
+                <a:cs typeface="Arial" pitchFamily="34" charset="-120"/>
               </a:rPr>
               <a:t>em antroposofia</a:t>
             </a:r>
@@ -8917,7 +8917,7 @@
     <p:bg>
       <p:bgPr>
         <a:solidFill>
-          <a:srgbClr val="1B4332"/>
+          <a:srgbClr val="5C1528"/>
         </a:solidFill>
       </p:bgPr>
     </p:bg>
@@ -8964,9 +8964,9 @@
                 <a:solidFill>
                   <a:srgbClr val="52B788"/>
                 </a:solidFill>
-                <a:latin typeface="Calibri" pitchFamily="34" charset="0"/>
-                <a:ea typeface="Calibri" pitchFamily="34" charset="-122"/>
-                <a:cs typeface="Calibri" pitchFamily="34" charset="-120"/>
+                <a:latin typeface="Arial" pitchFamily="34" charset="0"/>
+                <a:ea typeface="Arial" pitchFamily="34" charset="-122"/>
+                <a:cs typeface="Arial" pitchFamily="34" charset="-120"/>
               </a:rPr>
               <a:t>PARTE II</a:t>
             </a:r>
@@ -9065,9 +9065,9 @@
                 <a:solidFill>
                   <a:srgbClr val="D4821A"/>
                 </a:solidFill>
-                <a:latin typeface="Calibri" pitchFamily="34" charset="0"/>
-                <a:ea typeface="Calibri" pitchFamily="34" charset="-122"/>
-                <a:cs typeface="Calibri" pitchFamily="34" charset="-120"/>
+                <a:latin typeface="Arial" pitchFamily="34" charset="0"/>
+                <a:ea typeface="Arial" pitchFamily="34" charset="-122"/>
+                <a:cs typeface="Arial" pitchFamily="34" charset="-120"/>
               </a:rPr>
               <a:t>Conceito, metodologia de inferência e resultados do engajamento comunitário</a:t>
             </a:r>
@@ -9134,7 +9134,7 @@
             <a:r>
               <a:rPr lang="en-US" sz="2600" b="1" dirty="0">
                 <a:solidFill>
-                  <a:srgbClr val="1B4332"/>
+                  <a:srgbClr val="7B2230"/>
                 </a:solidFill>
                 <a:latin typeface="Cambria" pitchFamily="34" charset="0"/>
                 <a:ea typeface="Cambria" pitchFamily="34" charset="-122"/>
@@ -9173,11 +9173,11 @@
             <a:r>
               <a:rPr lang="en-US" sz="1200" i="1" dirty="0">
                 <a:solidFill>
-                  <a:srgbClr val="748C78"/>
-                </a:solidFill>
-                <a:latin typeface="Calibri" pitchFamily="34" charset="0"/>
-                <a:ea typeface="Calibri" pitchFamily="34" charset="-122"/>
-                <a:cs typeface="Calibri" pitchFamily="34" charset="-120"/>
+                  <a:srgbClr val="8A7070"/>
+                </a:solidFill>
+                <a:latin typeface="Arial" pitchFamily="34" charset="0"/>
+                <a:ea typeface="Arial" pitchFamily="34" charset="-122"/>
+                <a:cs typeface="Arial" pitchFamily="34" charset="-120"/>
               </a:rPr>
               <a:t>Uma trajetória de amadurecimento do indivíduo na comunidade escolar</a:t>
             </a:r>
@@ -9194,7 +9194,7 @@
         <p:spPr>
           <a:xfrm>
             <a:off x="457200" y="1051560"/>
-            <a:ext cx="8229600" cy="621792"/>
+            <a:ext cx="8229600" cy="438912"/>
           </a:xfrm>
           <a:prstGeom prst="rect">
             <a:avLst/>
@@ -9212,929 +9212,42 @@
             <a:r>
               <a:rPr lang="en-US" sz="1200" dirty="0">
                 <a:solidFill>
-                  <a:srgbClr val="1B2B1E"/>
-                </a:solidFill>
-                <a:latin typeface="Calibri" pitchFamily="34" charset="0"/>
-                <a:ea typeface="Calibri" pitchFamily="34" charset="-122"/>
-                <a:cs typeface="Calibri" pitchFamily="34" charset="-120"/>
-              </a:rPr>
-              <a:t>Originada da antroposofia, a curva descreve o caminho pelo qual cada membro de uma comunidade desenvolve seu pertencimento e contribuição. A lemniscata (símbolo do infinito) organiza os 7 estágios em dois lados: à esquerda, a construção do Capital Social Individual; à direita, a expressão do Capital Social Comunitário.</a:t>
+                  <a:srgbClr val="1B2420"/>
+                </a:solidFill>
+                <a:latin typeface="Arial" pitchFamily="34" charset="0"/>
+                <a:ea typeface="Arial" pitchFamily="34" charset="-122"/>
+                <a:cs typeface="Arial" pitchFamily="34" charset="-120"/>
+              </a:rPr>
+              <a:t>Originada da antroposofia, a curva descreve como cada membro da comunidade desenvolve seu pertencimento e contribuição. O ponto de virada — Comprometido — é o momento em que a pessoa diz SIM para o ser da escola.</a:t>
             </a:r>
             <a:endParaRPr lang="en-US" sz="1200" dirty="0"/>
           </a:p>
         </p:txBody>
       </p:sp>
-      <p:sp>
-        <p:nvSpPr>
-          <p:cNvPr id="5" name="Shape 3"/>
-          <p:cNvSpPr/>
-          <p:nvPr/>
-        </p:nvSpPr>
-        <p:spPr>
-          <a:xfrm>
-            <a:off x="457200" y="1938528"/>
-            <a:ext cx="1097280" cy="1005840"/>
-          </a:xfrm>
-          <a:prstGeom prst="rect">
-            <a:avLst/>
-          </a:prstGeom>
-          <a:solidFill>
-            <a:srgbClr val="CCCCCC"/>
-          </a:solidFill>
-          <a:ln w="12700">
-            <a:solidFill>
-              <a:srgbClr val="CCCCCC"/>
-            </a:solidFill>
-            <a:prstDash val="solid"/>
-          </a:ln>
-        </p:spPr>
-      </p:sp>
-      <p:sp>
-        <p:nvSpPr>
-          <p:cNvPr id="6" name="Text 4"/>
-          <p:cNvSpPr/>
-          <p:nvPr/>
-        </p:nvSpPr>
-        <p:spPr>
-          <a:xfrm>
-            <a:off x="457200" y="1938528"/>
-            <a:ext cx="1097280" cy="1005840"/>
-          </a:xfrm>
-          <a:prstGeom prst="rect">
-            <a:avLst/>
-          </a:prstGeom>
-          <a:noFill/>
-          <a:ln/>
-        </p:spPr>
-        <p:txBody>
-          <a:bodyPr wrap="square" lIns="0" tIns="0" rIns="0" bIns="0" rtlCol="0" anchor="ctr"/>
-          <a:lstStyle/>
-          <a:p>
-            <a:pPr algn="ctr" indent="0" marL="0">
-              <a:buNone/>
-            </a:pPr>
-            <a:r>
-              <a:rPr lang="en-US" sz="1000" b="1" dirty="0">
-                <a:solidFill>
-                  <a:srgbClr val="1B2B1E"/>
-                </a:solidFill>
-                <a:latin typeface="Calibri" pitchFamily="34" charset="0"/>
-                <a:ea typeface="Calibri" pitchFamily="34" charset="-122"/>
-                <a:cs typeface="Calibri" pitchFamily="34" charset="-120"/>
-              </a:rPr>
-              <a:t>1</a:t>
-            </a:r>
-            <a:endParaRPr lang="en-US" sz="1000" dirty="0"/>
-          </a:p>
-          <a:p>
-            <a:pPr algn="ctr" indent="0" marL="0">
-              <a:buNone/>
-            </a:pPr>
-            <a:r>
-              <a:rPr lang="en-US" sz="1000" b="1" dirty="0">
-                <a:solidFill>
-                  <a:srgbClr val="1B2B1E"/>
-                </a:solidFill>
-                <a:latin typeface="Calibri" pitchFamily="34" charset="0"/>
-                <a:ea typeface="Calibri" pitchFamily="34" charset="-122"/>
-                <a:cs typeface="Calibri" pitchFamily="34" charset="-120"/>
-              </a:rPr>
-              <a:t>Novo</a:t>
-            </a:r>
-            <a:endParaRPr lang="en-US" sz="1000" dirty="0"/>
-          </a:p>
-        </p:txBody>
-      </p:sp>
-      <p:sp>
-        <p:nvSpPr>
-          <p:cNvPr id="7" name="Shape 5"/>
-          <p:cNvSpPr/>
-          <p:nvPr/>
-        </p:nvSpPr>
-        <p:spPr>
-          <a:xfrm>
-            <a:off x="1645920" y="1938528"/>
-            <a:ext cx="1097280" cy="1005840"/>
-          </a:xfrm>
-          <a:prstGeom prst="rect">
-            <a:avLst/>
-          </a:prstGeom>
-          <a:solidFill>
-            <a:srgbClr val="FCA311"/>
-          </a:solidFill>
-          <a:ln w="12700">
-            <a:solidFill>
-              <a:srgbClr val="FCA311"/>
-            </a:solidFill>
-            <a:prstDash val="solid"/>
-          </a:ln>
-        </p:spPr>
-      </p:sp>
-      <p:sp>
-        <p:nvSpPr>
-          <p:cNvPr id="8" name="Text 6"/>
-          <p:cNvSpPr/>
-          <p:nvPr/>
-        </p:nvSpPr>
-        <p:spPr>
-          <a:xfrm>
-            <a:off x="1645920" y="1938528"/>
-            <a:ext cx="1097280" cy="1005840"/>
-          </a:xfrm>
-          <a:prstGeom prst="rect">
-            <a:avLst/>
-          </a:prstGeom>
-          <a:noFill/>
-          <a:ln/>
-        </p:spPr>
-        <p:txBody>
-          <a:bodyPr wrap="square" lIns="0" tIns="0" rIns="0" bIns="0" rtlCol="0" anchor="ctr"/>
-          <a:lstStyle/>
-          <a:p>
-            <a:pPr algn="ctr" indent="0" marL="0">
-              <a:buNone/>
-            </a:pPr>
-            <a:r>
-              <a:rPr lang="en-US" sz="1000" b="1" dirty="0">
-                <a:solidFill>
-                  <a:srgbClr val="FFFFFF"/>
-                </a:solidFill>
-                <a:latin typeface="Calibri" pitchFamily="34" charset="0"/>
-                <a:ea typeface="Calibri" pitchFamily="34" charset="-122"/>
-                <a:cs typeface="Calibri" pitchFamily="34" charset="-120"/>
-              </a:rPr>
-              <a:t>2</a:t>
-            </a:r>
-            <a:endParaRPr lang="en-US" sz="1000" dirty="0"/>
-          </a:p>
-          <a:p>
-            <a:pPr algn="ctr" indent="0" marL="0">
-              <a:buNone/>
-            </a:pPr>
-            <a:r>
-              <a:rPr lang="en-US" sz="1000" b="1" dirty="0">
-                <a:solidFill>
-                  <a:srgbClr val="FFFFFF"/>
-                </a:solidFill>
-                <a:latin typeface="Calibri" pitchFamily="34" charset="0"/>
-                <a:ea typeface="Calibri" pitchFamily="34" charset="-122"/>
-                <a:cs typeface="Calibri" pitchFamily="34" charset="-120"/>
-              </a:rPr>
-              <a:t>Adaptando</a:t>
-            </a:r>
-            <a:endParaRPr lang="en-US" sz="1000" dirty="0"/>
-          </a:p>
-        </p:txBody>
-      </p:sp>
-      <p:sp>
-        <p:nvSpPr>
-          <p:cNvPr id="9" name="Shape 7"/>
-          <p:cNvSpPr/>
-          <p:nvPr/>
-        </p:nvSpPr>
-        <p:spPr>
-          <a:xfrm>
-            <a:off x="2834640" y="1938528"/>
-            <a:ext cx="1097280" cy="1005840"/>
-          </a:xfrm>
-          <a:prstGeom prst="rect">
-            <a:avLst/>
-          </a:prstGeom>
-          <a:solidFill>
-            <a:srgbClr val="F4845F"/>
-          </a:solidFill>
-          <a:ln w="12700">
-            <a:solidFill>
-              <a:srgbClr val="F4845F"/>
-            </a:solidFill>
-            <a:prstDash val="solid"/>
-          </a:ln>
-        </p:spPr>
-      </p:sp>
-      <p:sp>
-        <p:nvSpPr>
-          <p:cNvPr id="10" name="Text 8"/>
-          <p:cNvSpPr/>
-          <p:nvPr/>
-        </p:nvSpPr>
-        <p:spPr>
-          <a:xfrm>
-            <a:off x="2834640" y="1938528"/>
-            <a:ext cx="1097280" cy="1005840"/>
-          </a:xfrm>
-          <a:prstGeom prst="rect">
-            <a:avLst/>
-          </a:prstGeom>
-          <a:noFill/>
-          <a:ln/>
-        </p:spPr>
-        <p:txBody>
-          <a:bodyPr wrap="square" lIns="0" tIns="0" rIns="0" bIns="0" rtlCol="0" anchor="ctr"/>
-          <a:lstStyle/>
-          <a:p>
-            <a:pPr algn="ctr" indent="0" marL="0">
-              <a:buNone/>
-            </a:pPr>
-            <a:r>
-              <a:rPr lang="en-US" sz="1000" b="1" dirty="0">
-                <a:solidFill>
-                  <a:srgbClr val="FFFFFF"/>
-                </a:solidFill>
-                <a:latin typeface="Calibri" pitchFamily="34" charset="0"/>
-                <a:ea typeface="Calibri" pitchFamily="34" charset="-122"/>
-                <a:cs typeface="Calibri" pitchFamily="34" charset="-120"/>
-              </a:rPr>
-              <a:t>3</a:t>
-            </a:r>
-            <a:endParaRPr lang="en-US" sz="1000" dirty="0"/>
-          </a:p>
-          <a:p>
-            <a:pPr algn="ctr" indent="0" marL="0">
-              <a:buNone/>
-            </a:pPr>
-            <a:r>
-              <a:rPr lang="en-US" sz="1000" b="1" dirty="0">
-                <a:solidFill>
-                  <a:srgbClr val="FFFFFF"/>
-                </a:solidFill>
-                <a:latin typeface="Calibri" pitchFamily="34" charset="0"/>
-                <a:ea typeface="Calibri" pitchFamily="34" charset="-122"/>
-                <a:cs typeface="Calibri" pitchFamily="34" charset="-120"/>
-              </a:rPr>
-              <a:t>Inserindo</a:t>
-            </a:r>
-            <a:endParaRPr lang="en-US" sz="1000" dirty="0"/>
-          </a:p>
-        </p:txBody>
-      </p:sp>
-      <p:sp>
-        <p:nvSpPr>
-          <p:cNvPr id="11" name="Shape 9"/>
-          <p:cNvSpPr/>
-          <p:nvPr/>
-        </p:nvSpPr>
-        <p:spPr>
-          <a:xfrm>
-            <a:off x="4023360" y="1828800"/>
-            <a:ext cx="1097280" cy="1234440"/>
-          </a:xfrm>
-          <a:prstGeom prst="rect">
-            <a:avLst/>
-          </a:prstGeom>
-          <a:solidFill>
-            <a:srgbClr val="2A9D8F"/>
-          </a:solidFill>
-          <a:ln w="12700">
-            <a:solidFill>
-              <a:srgbClr val="2A9D8F"/>
-            </a:solidFill>
-            <a:prstDash val="solid"/>
-          </a:ln>
-        </p:spPr>
-      </p:sp>
-      <p:sp>
-        <p:nvSpPr>
-          <p:cNvPr id="12" name="Text 10"/>
-          <p:cNvSpPr/>
-          <p:nvPr/>
-        </p:nvSpPr>
-        <p:spPr>
-          <a:xfrm>
-            <a:off x="4023360" y="1828800"/>
-            <a:ext cx="1097280" cy="1234440"/>
-          </a:xfrm>
-          <a:prstGeom prst="rect">
-            <a:avLst/>
-          </a:prstGeom>
-          <a:noFill/>
-          <a:ln/>
-        </p:spPr>
-        <p:txBody>
-          <a:bodyPr wrap="square" lIns="0" tIns="0" rIns="0" bIns="0" rtlCol="0" anchor="ctr"/>
-          <a:lstStyle/>
-          <a:p>
-            <a:pPr algn="ctr" indent="0" marL="0">
-              <a:buNone/>
-            </a:pPr>
-            <a:r>
-              <a:rPr lang="en-US" sz="1000" b="1" dirty="0">
-                <a:solidFill>
-                  <a:srgbClr val="FFFFFF"/>
-                </a:solidFill>
-                <a:latin typeface="Calibri" pitchFamily="34" charset="0"/>
-                <a:ea typeface="Calibri" pitchFamily="34" charset="-122"/>
-                <a:cs typeface="Calibri" pitchFamily="34" charset="-120"/>
-              </a:rPr>
-              <a:t>4</a:t>
-            </a:r>
-            <a:endParaRPr lang="en-US" sz="1000" dirty="0"/>
-          </a:p>
-          <a:p>
-            <a:pPr algn="ctr" indent="0" marL="0">
-              <a:buNone/>
-            </a:pPr>
-            <a:r>
-              <a:rPr lang="en-US" sz="1000" b="1" dirty="0">
-                <a:solidFill>
-                  <a:srgbClr val="FFFFFF"/>
-                </a:solidFill>
-                <a:latin typeface="Calibri" pitchFamily="34" charset="0"/>
-                <a:ea typeface="Calibri" pitchFamily="34" charset="-122"/>
-                <a:cs typeface="Calibri" pitchFamily="34" charset="-120"/>
-              </a:rPr>
-              <a:t>Comprometido</a:t>
-            </a:r>
-            <a:endParaRPr lang="en-US" sz="1000" dirty="0"/>
-          </a:p>
-        </p:txBody>
-      </p:sp>
-      <p:sp>
-        <p:nvSpPr>
-          <p:cNvPr id="13" name="Shape 11"/>
-          <p:cNvSpPr/>
-          <p:nvPr/>
-        </p:nvSpPr>
-        <p:spPr>
-          <a:xfrm>
-            <a:off x="5212080" y="1938528"/>
-            <a:ext cx="1097280" cy="1005840"/>
-          </a:xfrm>
-          <a:prstGeom prst="rect">
-            <a:avLst/>
-          </a:prstGeom>
-          <a:solidFill>
-            <a:srgbClr val="3B82C4"/>
-          </a:solidFill>
-          <a:ln w="12700">
-            <a:solidFill>
-              <a:srgbClr val="3B82C4"/>
-            </a:solidFill>
-            <a:prstDash val="solid"/>
-          </a:ln>
-        </p:spPr>
-      </p:sp>
-      <p:sp>
-        <p:nvSpPr>
-          <p:cNvPr id="14" name="Text 12"/>
-          <p:cNvSpPr/>
-          <p:nvPr/>
-        </p:nvSpPr>
-        <p:spPr>
-          <a:xfrm>
-            <a:off x="5212080" y="1938528"/>
-            <a:ext cx="1097280" cy="1005840"/>
-          </a:xfrm>
-          <a:prstGeom prst="rect">
-            <a:avLst/>
-          </a:prstGeom>
-          <a:noFill/>
-          <a:ln/>
-        </p:spPr>
-        <p:txBody>
-          <a:bodyPr wrap="square" lIns="0" tIns="0" rIns="0" bIns="0" rtlCol="0" anchor="ctr"/>
-          <a:lstStyle/>
-          <a:p>
-            <a:pPr algn="ctr" indent="0" marL="0">
-              <a:buNone/>
-            </a:pPr>
-            <a:r>
-              <a:rPr lang="en-US" sz="1000" b="1" dirty="0">
-                <a:solidFill>
-                  <a:srgbClr val="FFFFFF"/>
-                </a:solidFill>
-                <a:latin typeface="Calibri" pitchFamily="34" charset="0"/>
-                <a:ea typeface="Calibri" pitchFamily="34" charset="-122"/>
-                <a:cs typeface="Calibri" pitchFamily="34" charset="-120"/>
-              </a:rPr>
-              <a:t>5</a:t>
-            </a:r>
-            <a:endParaRPr lang="en-US" sz="1000" dirty="0"/>
-          </a:p>
-          <a:p>
-            <a:pPr algn="ctr" indent="0" marL="0">
-              <a:buNone/>
-            </a:pPr>
-            <a:r>
-              <a:rPr lang="en-US" sz="1000" b="1" dirty="0">
-                <a:solidFill>
-                  <a:srgbClr val="FFFFFF"/>
-                </a:solidFill>
-                <a:latin typeface="Calibri" pitchFamily="34" charset="0"/>
-                <a:ea typeface="Calibri" pitchFamily="34" charset="-122"/>
-                <a:cs typeface="Calibri" pitchFamily="34" charset="-120"/>
-              </a:rPr>
-              <a:t>Ativo no</a:t>
-            </a:r>
-            <a:endParaRPr lang="en-US" sz="1000" dirty="0"/>
-          </a:p>
-          <a:p>
-            <a:pPr algn="ctr" indent="0" marL="0">
-              <a:buNone/>
-            </a:pPr>
-            <a:r>
-              <a:rPr lang="en-US" sz="1000" b="1" dirty="0">
-                <a:solidFill>
-                  <a:srgbClr val="FFFFFF"/>
-                </a:solidFill>
-                <a:latin typeface="Calibri" pitchFamily="34" charset="0"/>
-                <a:ea typeface="Calibri" pitchFamily="34" charset="-122"/>
-                <a:cs typeface="Calibri" pitchFamily="34" charset="-120"/>
-              </a:rPr>
-              <a:t>Motivo</a:t>
-            </a:r>
-            <a:endParaRPr lang="en-US" sz="1000" dirty="0"/>
-          </a:p>
-        </p:txBody>
-      </p:sp>
-      <p:sp>
-        <p:nvSpPr>
-          <p:cNvPr id="15" name="Shape 13"/>
-          <p:cNvSpPr/>
-          <p:nvPr/>
-        </p:nvSpPr>
-        <p:spPr>
-          <a:xfrm>
-            <a:off x="6400800" y="1938528"/>
-            <a:ext cx="1097280" cy="1005840"/>
-          </a:xfrm>
-          <a:prstGeom prst="rect">
-            <a:avLst/>
-          </a:prstGeom>
-          <a:solidFill>
-            <a:srgbClr val="1D5B7A"/>
-          </a:solidFill>
-          <a:ln w="12700">
-            <a:solidFill>
-              <a:srgbClr val="1D5B7A"/>
-            </a:solidFill>
-            <a:prstDash val="solid"/>
-          </a:ln>
-        </p:spPr>
-      </p:sp>
-      <p:sp>
-        <p:nvSpPr>
-          <p:cNvPr id="16" name="Text 14"/>
-          <p:cNvSpPr/>
-          <p:nvPr/>
-        </p:nvSpPr>
-        <p:spPr>
-          <a:xfrm>
-            <a:off x="6400800" y="1938528"/>
-            <a:ext cx="1097280" cy="1005840"/>
-          </a:xfrm>
-          <a:prstGeom prst="rect">
-            <a:avLst/>
-          </a:prstGeom>
-          <a:noFill/>
-          <a:ln/>
-        </p:spPr>
-        <p:txBody>
-          <a:bodyPr wrap="square" lIns="0" tIns="0" rIns="0" bIns="0" rtlCol="0" anchor="ctr"/>
-          <a:lstStyle/>
-          <a:p>
-            <a:pPr algn="ctr" indent="0" marL="0">
-              <a:buNone/>
-            </a:pPr>
-            <a:r>
-              <a:rPr lang="en-US" sz="1000" b="1" dirty="0">
-                <a:solidFill>
-                  <a:srgbClr val="FFFFFF"/>
-                </a:solidFill>
-                <a:latin typeface="Calibri" pitchFamily="34" charset="0"/>
-                <a:ea typeface="Calibri" pitchFamily="34" charset="-122"/>
-                <a:cs typeface="Calibri" pitchFamily="34" charset="-120"/>
-              </a:rPr>
-              <a:t>6</a:t>
-            </a:r>
-            <a:endParaRPr lang="en-US" sz="1000" dirty="0"/>
-          </a:p>
-          <a:p>
-            <a:pPr algn="ctr" indent="0" marL="0">
-              <a:buNone/>
-            </a:pPr>
-            <a:r>
-              <a:rPr lang="en-US" sz="1000" b="1" dirty="0">
-                <a:solidFill>
-                  <a:srgbClr val="FFFFFF"/>
-                </a:solidFill>
-                <a:latin typeface="Calibri" pitchFamily="34" charset="0"/>
-                <a:ea typeface="Calibri" pitchFamily="34" charset="-122"/>
-                <a:cs typeface="Calibri" pitchFamily="34" charset="-120"/>
-              </a:rPr>
-              <a:t>Embaixador</a:t>
-            </a:r>
-            <a:endParaRPr lang="en-US" sz="1000" dirty="0"/>
-          </a:p>
-        </p:txBody>
-      </p:sp>
-      <p:sp>
-        <p:nvSpPr>
-          <p:cNvPr id="17" name="Shape 15"/>
-          <p:cNvSpPr/>
-          <p:nvPr/>
-        </p:nvSpPr>
-        <p:spPr>
-          <a:xfrm>
-            <a:off x="7589520" y="1938528"/>
-            <a:ext cx="1097280" cy="1005840"/>
-          </a:xfrm>
-          <a:prstGeom prst="rect">
-            <a:avLst/>
-          </a:prstGeom>
-          <a:solidFill>
-            <a:srgbClr val="6B46C1"/>
-          </a:solidFill>
-          <a:ln w="12700">
-            <a:solidFill>
-              <a:srgbClr val="6B46C1"/>
-            </a:solidFill>
-            <a:prstDash val="solid"/>
-          </a:ln>
-        </p:spPr>
-      </p:sp>
-      <p:sp>
-        <p:nvSpPr>
-          <p:cNvPr id="18" name="Text 16"/>
-          <p:cNvSpPr/>
-          <p:nvPr/>
-        </p:nvSpPr>
-        <p:spPr>
-          <a:xfrm>
-            <a:off x="7589520" y="1938528"/>
-            <a:ext cx="1097280" cy="1005840"/>
-          </a:xfrm>
-          <a:prstGeom prst="rect">
-            <a:avLst/>
-          </a:prstGeom>
-          <a:noFill/>
-          <a:ln/>
-        </p:spPr>
-        <p:txBody>
-          <a:bodyPr wrap="square" lIns="0" tIns="0" rIns="0" bIns="0" rtlCol="0" anchor="ctr"/>
-          <a:lstStyle/>
-          <a:p>
-            <a:pPr algn="ctr" indent="0" marL="0">
-              <a:buNone/>
-            </a:pPr>
-            <a:r>
-              <a:rPr lang="en-US" sz="1000" b="1" dirty="0">
-                <a:solidFill>
-                  <a:srgbClr val="FFFFFF"/>
-                </a:solidFill>
-                <a:latin typeface="Calibri" pitchFamily="34" charset="0"/>
-                <a:ea typeface="Calibri" pitchFamily="34" charset="-122"/>
-                <a:cs typeface="Calibri" pitchFamily="34" charset="-120"/>
-              </a:rPr>
-              <a:t>7</a:t>
-            </a:r>
-            <a:endParaRPr lang="en-US" sz="1000" dirty="0"/>
-          </a:p>
-          <a:p>
-            <a:pPr algn="ctr" indent="0" marL="0">
-              <a:buNone/>
-            </a:pPr>
-            <a:r>
-              <a:rPr lang="en-US" sz="1000" b="1" dirty="0">
-                <a:solidFill>
-                  <a:srgbClr val="FFFFFF"/>
-                </a:solidFill>
-                <a:latin typeface="Calibri" pitchFamily="34" charset="0"/>
-                <a:ea typeface="Calibri" pitchFamily="34" charset="-122"/>
-                <a:cs typeface="Calibri" pitchFamily="34" charset="-120"/>
-              </a:rPr>
-              <a:t>Cocriador</a:t>
-            </a:r>
-            <a:endParaRPr lang="en-US" sz="1000" dirty="0"/>
-          </a:p>
-        </p:txBody>
-      </p:sp>
-      <p:sp>
-        <p:nvSpPr>
-          <p:cNvPr id="19" name="Shape 17"/>
-          <p:cNvSpPr/>
-          <p:nvPr/>
-        </p:nvSpPr>
-        <p:spPr>
-          <a:xfrm>
-            <a:off x="3456432" y="1719072"/>
-            <a:ext cx="36576" cy="1554480"/>
-          </a:xfrm>
-          <a:prstGeom prst="rect">
-            <a:avLst/>
-          </a:prstGeom>
-          <a:solidFill>
-            <a:srgbClr val="D4821A"/>
-          </a:solidFill>
-          <a:ln w="12700">
-            <a:solidFill>
-              <a:srgbClr val="D4821A"/>
-            </a:solidFill>
-            <a:prstDash val="solid"/>
-          </a:ln>
-        </p:spPr>
-      </p:sp>
-      <p:sp>
-        <p:nvSpPr>
-          <p:cNvPr id="20" name="Text 18"/>
-          <p:cNvSpPr/>
-          <p:nvPr/>
-        </p:nvSpPr>
-        <p:spPr>
-          <a:xfrm>
-            <a:off x="3017520" y="1481328"/>
-            <a:ext cx="914400" cy="347472"/>
-          </a:xfrm>
-          <a:prstGeom prst="rect">
-            <a:avLst/>
-          </a:prstGeom>
-          <a:noFill/>
-          <a:ln/>
-        </p:spPr>
-        <p:txBody>
-          <a:bodyPr wrap="square" lIns="0" tIns="0" rIns="0" bIns="0" rtlCol="0" anchor="ctr"/>
-          <a:lstStyle/>
-          <a:p>
-            <a:pPr algn="ctr" indent="0" marL="0">
-              <a:buNone/>
-            </a:pPr>
-            <a:r>
-              <a:rPr lang="en-US" sz="800" b="1" dirty="0">
-                <a:solidFill>
-                  <a:srgbClr val="D4821A"/>
-                </a:solidFill>
-                <a:latin typeface="Calibri" pitchFamily="34" charset="0"/>
-                <a:ea typeface="Calibri" pitchFamily="34" charset="-122"/>
-                <a:cs typeface="Calibri" pitchFamily="34" charset="-120"/>
-              </a:rPr>
-              <a:t>PONTO DE</a:t>
-            </a:r>
-            <a:endParaRPr lang="en-US" sz="800" dirty="0"/>
-          </a:p>
-          <a:p>
-            <a:pPr algn="ctr" indent="0" marL="0">
-              <a:buNone/>
-            </a:pPr>
-            <a:r>
-              <a:rPr lang="en-US" sz="800" b="1" dirty="0">
-                <a:solidFill>
-                  <a:srgbClr val="D4821A"/>
-                </a:solidFill>
-                <a:latin typeface="Calibri" pitchFamily="34" charset="0"/>
-                <a:ea typeface="Calibri" pitchFamily="34" charset="-122"/>
-                <a:cs typeface="Calibri" pitchFamily="34" charset="-120"/>
-              </a:rPr>
-              <a:t>VIRADA</a:t>
-            </a:r>
-            <a:endParaRPr lang="en-US" sz="800" dirty="0"/>
-          </a:p>
-        </p:txBody>
-      </p:sp>
-      <p:sp>
-        <p:nvSpPr>
-          <p:cNvPr id="21" name="Text 19"/>
-          <p:cNvSpPr/>
-          <p:nvPr/>
-        </p:nvSpPr>
-        <p:spPr>
-          <a:xfrm>
-            <a:off x="457200" y="3246120"/>
-            <a:ext cx="3383280" cy="274320"/>
-          </a:xfrm>
-          <a:prstGeom prst="rect">
-            <a:avLst/>
-          </a:prstGeom>
-          <a:noFill/>
-          <a:ln/>
-        </p:spPr>
-        <p:txBody>
-          <a:bodyPr wrap="square" lIns="0" tIns="0" rIns="0" bIns="0" rtlCol="0" anchor="ctr"/>
-          <a:lstStyle/>
-          <a:p>
-            <a:pPr algn="ctr" indent="0" marL="0">
-              <a:buNone/>
-            </a:pPr>
-            <a:r>
-              <a:rPr lang="en-US" sz="1100" b="1" i="1" dirty="0">
-                <a:solidFill>
-                  <a:srgbClr val="748C78"/>
-                </a:solidFill>
-                <a:latin typeface="Cambria" pitchFamily="34" charset="0"/>
-                <a:ea typeface="Cambria" pitchFamily="34" charset="-122"/>
-                <a:cs typeface="Cambria" pitchFamily="34" charset="-120"/>
-              </a:rPr>
-              <a:t>Capital Social Individual</a:t>
-            </a:r>
-            <a:endParaRPr lang="en-US" sz="1100" dirty="0"/>
-          </a:p>
-        </p:txBody>
-      </p:sp>
-      <p:sp>
-        <p:nvSpPr>
-          <p:cNvPr id="22" name="Text 20"/>
-          <p:cNvSpPr/>
-          <p:nvPr/>
-        </p:nvSpPr>
-        <p:spPr>
-          <a:xfrm>
-            <a:off x="3566160" y="3246120"/>
-            <a:ext cx="5120640" cy="274320"/>
-          </a:xfrm>
-          <a:prstGeom prst="rect">
-            <a:avLst/>
-          </a:prstGeom>
-          <a:noFill/>
-          <a:ln/>
-        </p:spPr>
-        <p:txBody>
-          <a:bodyPr wrap="square" lIns="0" tIns="0" rIns="0" bIns="0" rtlCol="0" anchor="ctr"/>
-          <a:lstStyle/>
-          <a:p>
-            <a:pPr algn="ctr" indent="0" marL="0">
-              <a:buNone/>
-            </a:pPr>
-            <a:r>
-              <a:rPr lang="en-US" sz="1100" b="1" i="1" dirty="0">
-                <a:solidFill>
-                  <a:srgbClr val="2D6A4F"/>
-                </a:solidFill>
-                <a:latin typeface="Cambria" pitchFamily="34" charset="0"/>
-                <a:ea typeface="Cambria" pitchFamily="34" charset="-122"/>
-                <a:cs typeface="Cambria" pitchFamily="34" charset="-120"/>
-              </a:rPr>
-              <a:t>Capital Social Comunitário</a:t>
-            </a:r>
-            <a:endParaRPr lang="en-US" sz="1100" dirty="0"/>
-          </a:p>
-        </p:txBody>
-      </p:sp>
-      <p:sp>
-        <p:nvSpPr>
-          <p:cNvPr id="23" name="Text 21"/>
-          <p:cNvSpPr/>
-          <p:nvPr/>
-        </p:nvSpPr>
-        <p:spPr>
-          <a:xfrm>
-            <a:off x="457200" y="3566160"/>
-            <a:ext cx="2651760" cy="457200"/>
-          </a:xfrm>
-          <a:prstGeom prst="rect">
-            <a:avLst/>
-          </a:prstGeom>
-          <a:noFill/>
-          <a:ln/>
-        </p:spPr>
-        <p:txBody>
-          <a:bodyPr wrap="square" lIns="0" tIns="0" rIns="0" bIns="0" rtlCol="0" anchor="ctr"/>
-          <a:lstStyle/>
-          <a:p>
-            <a:pPr algn="ctr" indent="0" marL="0">
-              <a:buNone/>
-            </a:pPr>
-            <a:r>
-              <a:rPr lang="en-US" sz="1000" i="1" dirty="0">
-                <a:solidFill>
-                  <a:srgbClr val="748C78"/>
-                </a:solidFill>
-                <a:latin typeface="Calibri" pitchFamily="34" charset="0"/>
-                <a:ea typeface="Calibri" pitchFamily="34" charset="-122"/>
-                <a:cs typeface="Calibri" pitchFamily="34" charset="-120"/>
-              </a:rPr>
-              <a:t>Fases de reconhecimento</a:t>
-            </a:r>
-            <a:endParaRPr lang="en-US" sz="1000" dirty="0"/>
-          </a:p>
-          <a:p>
-            <a:pPr algn="ctr" indent="0" marL="0">
-              <a:buNone/>
-            </a:pPr>
-            <a:r>
-              <a:rPr lang="en-US" sz="1000" i="1" dirty="0">
-                <a:solidFill>
-                  <a:srgbClr val="748C78"/>
-                </a:solidFill>
-                <a:latin typeface="Calibri" pitchFamily="34" charset="0"/>
-                <a:ea typeface="Calibri" pitchFamily="34" charset="-122"/>
-                <a:cs typeface="Calibri" pitchFamily="34" charset="-120"/>
-              </a:rPr>
-              <a:t>e adaptação à escola</a:t>
-            </a:r>
-            <a:endParaRPr lang="en-US" sz="1000" dirty="0"/>
-          </a:p>
-        </p:txBody>
-      </p:sp>
-      <p:sp>
-        <p:nvSpPr>
-          <p:cNvPr id="24" name="Text 22"/>
-          <p:cNvSpPr/>
-          <p:nvPr/>
-        </p:nvSpPr>
-        <p:spPr>
-          <a:xfrm>
-            <a:off x="3566160" y="3566160"/>
-            <a:ext cx="2651760" cy="457200"/>
-          </a:xfrm>
-          <a:prstGeom prst="rect">
-            <a:avLst/>
-          </a:prstGeom>
-          <a:noFill/>
-          <a:ln/>
-        </p:spPr>
-        <p:txBody>
-          <a:bodyPr wrap="square" lIns="0" tIns="0" rIns="0" bIns="0" rtlCol="0" anchor="ctr"/>
-          <a:lstStyle/>
-          <a:p>
-            <a:pPr algn="ctr" indent="0" marL="0">
-              <a:buNone/>
-            </a:pPr>
-            <a:r>
-              <a:rPr lang="en-US" sz="1000" i="1" dirty="0">
-                <a:solidFill>
-                  <a:srgbClr val="748C78"/>
-                </a:solidFill>
-                <a:latin typeface="Calibri" pitchFamily="34" charset="0"/>
-                <a:ea typeface="Calibri" pitchFamily="34" charset="-122"/>
-                <a:cs typeface="Calibri" pitchFamily="34" charset="-120"/>
-              </a:rPr>
-              <a:t>"Disse SIM" — ponto de compromisso</a:t>
-            </a:r>
-            <a:endParaRPr lang="en-US" sz="1000" dirty="0"/>
-          </a:p>
-          <a:p>
-            <a:pPr algn="ctr" indent="0" marL="0">
-              <a:buNone/>
-            </a:pPr>
-            <a:r>
-              <a:rPr lang="en-US" sz="1000" i="1" dirty="0">
-                <a:solidFill>
-                  <a:srgbClr val="748C78"/>
-                </a:solidFill>
-                <a:latin typeface="Calibri" pitchFamily="34" charset="0"/>
-                <a:ea typeface="Calibri" pitchFamily="34" charset="-122"/>
-                <a:cs typeface="Calibri" pitchFamily="34" charset="-120"/>
-              </a:rPr>
-              <a:t>com a comunidade</a:t>
-            </a:r>
-            <a:endParaRPr lang="en-US" sz="1000" dirty="0"/>
-          </a:p>
-        </p:txBody>
-      </p:sp>
-      <p:sp>
-        <p:nvSpPr>
-          <p:cNvPr id="25" name="Text 23"/>
-          <p:cNvSpPr/>
-          <p:nvPr/>
-        </p:nvSpPr>
-        <p:spPr>
-          <a:xfrm>
-            <a:off x="5943600" y="3566160"/>
-            <a:ext cx="2651760" cy="457200"/>
-          </a:xfrm>
-          <a:prstGeom prst="rect">
-            <a:avLst/>
-          </a:prstGeom>
-          <a:noFill/>
-          <a:ln/>
-        </p:spPr>
-        <p:txBody>
-          <a:bodyPr wrap="square" lIns="0" tIns="0" rIns="0" bIns="0" rtlCol="0" anchor="ctr"/>
-          <a:lstStyle/>
-          <a:p>
-            <a:pPr algn="ctr" indent="0" marL="0">
-              <a:buNone/>
-            </a:pPr>
-            <a:r>
-              <a:rPr lang="en-US" sz="1000" i="1" dirty="0">
-                <a:solidFill>
-                  <a:srgbClr val="748C78"/>
-                </a:solidFill>
-                <a:latin typeface="Calibri" pitchFamily="34" charset="0"/>
-                <a:ea typeface="Calibri" pitchFamily="34" charset="-122"/>
-                <a:cs typeface="Calibri" pitchFamily="34" charset="-120"/>
-              </a:rPr>
-              <a:t>Co-cria ativamente</a:t>
-            </a:r>
-            <a:endParaRPr lang="en-US" sz="1000" dirty="0"/>
-          </a:p>
-          <a:p>
-            <a:pPr algn="ctr" indent="0" marL="0">
-              <a:buNone/>
-            </a:pPr>
-            <a:r>
-              <a:rPr lang="en-US" sz="1000" i="1" dirty="0">
-                <a:solidFill>
-                  <a:srgbClr val="748C78"/>
-                </a:solidFill>
-                <a:latin typeface="Calibri" pitchFamily="34" charset="0"/>
-                <a:ea typeface="Calibri" pitchFamily="34" charset="-122"/>
-                <a:cs typeface="Calibri" pitchFamily="34" charset="-120"/>
-              </a:rPr>
-              <a:t>o futuro da escola</a:t>
-            </a:r>
-            <a:endParaRPr lang="en-US" sz="1000" dirty="0"/>
-          </a:p>
-        </p:txBody>
-      </p:sp>
+      <p:pic>
+        <p:nvPicPr>
+          <p:cNvPr id="5" name="Image 0" descr="preencoded.png">    </p:cNvPr>
+          <p:cNvPicPr>
+            <a:picLocks noChangeAspect="1"/>
+          </p:cNvPicPr>
+          <p:nvPr/>
+        </p:nvPicPr>
+        <p:blipFill>
+          <a:blip r:embed="rId1"/>
+          <a:stretch>
+            <a:fillRect/>
+          </a:stretch>
+        </p:blipFill>
+        <p:spPr>
+          <a:xfrm>
+            <a:off x="457200" y="1508760"/>
+            <a:ext cx="8229600" cy="3429000"/>
+          </a:xfrm>
+          <a:prstGeom prst="rect">
+            <a:avLst/>
+          </a:prstGeom>
+        </p:spPr>
+      </p:pic>
     </p:spTree>
   </p:cSld>
   <p:clrMapOvr>
@@ -10194,7 +9307,7 @@
             <a:r>
               <a:rPr lang="en-US" sz="2600" b="1" dirty="0">
                 <a:solidFill>
-                  <a:srgbClr val="1B4332"/>
+                  <a:srgbClr val="7B2230"/>
                 </a:solidFill>
                 <a:latin typeface="Cambria" pitchFamily="34" charset="0"/>
                 <a:ea typeface="Cambria" pitchFamily="34" charset="-122"/>
@@ -10233,11 +9346,11 @@
             <a:r>
               <a:rPr lang="en-US" sz="1200" i="1" dirty="0">
                 <a:solidFill>
-                  <a:srgbClr val="748C78"/>
-                </a:solidFill>
-                <a:latin typeface="Calibri" pitchFamily="34" charset="0"/>
-                <a:ea typeface="Calibri" pitchFamily="34" charset="-122"/>
-                <a:cs typeface="Calibri" pitchFamily="34" charset="-120"/>
+                  <a:srgbClr val="8A7070"/>
+                </a:solidFill>
+                <a:latin typeface="Arial" pitchFamily="34" charset="0"/>
+                <a:ea typeface="Arial" pitchFamily="34" charset="-122"/>
+                <a:cs typeface="Arial" pitchFamily="34" charset="-120"/>
               </a:rPr>
               <a:t>Como as respostas foram interpretadas para posicionar cada pessoa na curva</a:t>
             </a:r>
@@ -10254,7 +9367,7 @@
         <p:spPr>
           <a:xfrm>
             <a:off x="457200" y="1051560"/>
-            <a:ext cx="8229600" cy="347472"/>
+            <a:ext cx="8229600" cy="320040"/>
           </a:xfrm>
           <a:prstGeom prst="rect">
             <a:avLst/>
@@ -10272,13 +9385,13 @@
             <a:r>
               <a:rPr lang="en-US" sz="1200" dirty="0">
                 <a:solidFill>
-                  <a:srgbClr val="1B2B1E"/>
-                </a:solidFill>
-                <a:latin typeface="Calibri" pitchFamily="34" charset="0"/>
-                <a:ea typeface="Calibri" pitchFamily="34" charset="-122"/>
-                <a:cs typeface="Calibri" pitchFamily="34" charset="-120"/>
-              </a:rPr>
-              <a:t>Para cada respondente, o estágio foi inferido combinando cinco dimensões de análise, com pesos distintos:</a:t>
+                  <a:srgbClr val="1B2420"/>
+                </a:solidFill>
+                <a:latin typeface="Arial" pitchFamily="34" charset="0"/>
+                <a:ea typeface="Arial" pitchFamily="34" charset="-122"/>
+                <a:cs typeface="Arial" pitchFamily="34" charset="-120"/>
+              </a:rPr>
+              <a:t>Para cada respondente, o estágio foi inferido combinando cinco dimensões de análise:</a:t>
             </a:r>
             <a:endParaRPr lang="en-US" sz="1200" dirty="0"/>
           </a:p>
@@ -10293,6 +9406,212 @@
         <p:spPr>
           <a:xfrm>
             <a:off x="457200" y="1371600"/>
+            <a:ext cx="164592" cy="475488"/>
+          </a:xfrm>
+          <a:prstGeom prst="rect">
+            <a:avLst/>
+          </a:prstGeom>
+          <a:solidFill>
+            <a:srgbClr val="7B2230"/>
+          </a:solidFill>
+          <a:ln w="12700">
+            <a:solidFill>
+              <a:srgbClr val="7B2230"/>
+            </a:solidFill>
+            <a:prstDash val="solid"/>
+          </a:ln>
+        </p:spPr>
+      </p:sp>
+      <p:sp>
+        <p:nvSpPr>
+          <p:cNvPr id="6" name="Text 4"/>
+          <p:cNvSpPr/>
+          <p:nvPr/>
+        </p:nvSpPr>
+        <p:spPr>
+          <a:xfrm>
+            <a:off x="713232" y="1371600"/>
+            <a:ext cx="3200400" cy="237744"/>
+          </a:xfrm>
+          <a:prstGeom prst="rect">
+            <a:avLst/>
+          </a:prstGeom>
+          <a:noFill/>
+          <a:ln/>
+        </p:spPr>
+        <p:txBody>
+          <a:bodyPr wrap="square" lIns="0" tIns="0" rIns="0" bIns="0" rtlCol="0" anchor="ctr"/>
+          <a:lstStyle/>
+          <a:p>
+            <a:pPr indent="0" marL="0">
+              <a:buNone/>
+            </a:pPr>
+            <a:r>
+              <a:rPr lang="en-US" sz="1200" b="1" dirty="0">
+                <a:solidFill>
+                  <a:srgbClr val="1B2420"/>
+                </a:solidFill>
+                <a:latin typeface="Cambria" pitchFamily="34" charset="0"/>
+                <a:ea typeface="Cambria" pitchFamily="34" charset="-122"/>
+                <a:cs typeface="Cambria" pitchFamily="34" charset="-120"/>
+              </a:rPr>
+              <a:t>Conhecimento Institucional</a:t>
+            </a:r>
+            <a:endParaRPr lang="en-US" sz="1200" dirty="0"/>
+          </a:p>
+        </p:txBody>
+      </p:sp>
+      <p:sp>
+        <p:nvSpPr>
+          <p:cNvPr id="7" name="Text 5"/>
+          <p:cNvSpPr/>
+          <p:nvPr/>
+        </p:nvSpPr>
+        <p:spPr>
+          <a:xfrm>
+            <a:off x="713232" y="1600200"/>
+            <a:ext cx="7315200" cy="237744"/>
+          </a:xfrm>
+          <a:prstGeom prst="rect">
+            <a:avLst/>
+          </a:prstGeom>
+          <a:noFill/>
+          <a:ln/>
+        </p:spPr>
+        <p:txBody>
+          <a:bodyPr wrap="square" lIns="0" tIns="0" rIns="0" bIns="0" rtlCol="0" anchor="ctr"/>
+          <a:lstStyle/>
+          <a:p>
+            <a:pPr indent="0" marL="0">
+              <a:buNone/>
+            </a:pPr>
+            <a:r>
+              <a:rPr lang="en-US" sz="1000" dirty="0">
+                <a:solidFill>
+                  <a:srgbClr val="8A7070"/>
+                </a:solidFill>
+                <a:latin typeface="Arial" pitchFamily="34" charset="0"/>
+                <a:ea typeface="Arial" pitchFamily="34" charset="-122"/>
+                <a:cs typeface="Arial" pitchFamily="34" charset="-120"/>
+              </a:rPr>
+              <a:t>Sim/Não sobre 4 aspectos-chave (missão, processos, pedagogia)</a:t>
+            </a:r>
+            <a:endParaRPr lang="en-US" sz="1000" dirty="0"/>
+          </a:p>
+        </p:txBody>
+      </p:sp>
+      <p:sp>
+        <p:nvSpPr>
+          <p:cNvPr id="8" name="Shape 6"/>
+          <p:cNvSpPr/>
+          <p:nvPr/>
+        </p:nvSpPr>
+        <p:spPr>
+          <a:xfrm>
+            <a:off x="457200" y="1993392"/>
+            <a:ext cx="164592" cy="475488"/>
+          </a:xfrm>
+          <a:prstGeom prst="rect">
+            <a:avLst/>
+          </a:prstGeom>
+          <a:solidFill>
+            <a:srgbClr val="457B9D"/>
+          </a:solidFill>
+          <a:ln w="12700">
+            <a:solidFill>
+              <a:srgbClr val="457B9D"/>
+            </a:solidFill>
+            <a:prstDash val="solid"/>
+          </a:ln>
+        </p:spPr>
+      </p:sp>
+      <p:sp>
+        <p:nvSpPr>
+          <p:cNvPr id="9" name="Text 7"/>
+          <p:cNvSpPr/>
+          <p:nvPr/>
+        </p:nvSpPr>
+        <p:spPr>
+          <a:xfrm>
+            <a:off x="713232" y="1993392"/>
+            <a:ext cx="3200400" cy="237744"/>
+          </a:xfrm>
+          <a:prstGeom prst="rect">
+            <a:avLst/>
+          </a:prstGeom>
+          <a:noFill/>
+          <a:ln/>
+        </p:spPr>
+        <p:txBody>
+          <a:bodyPr wrap="square" lIns="0" tIns="0" rIns="0" bIns="0" rtlCol="0" anchor="ctr"/>
+          <a:lstStyle/>
+          <a:p>
+            <a:pPr indent="0" marL="0">
+              <a:buNone/>
+            </a:pPr>
+            <a:r>
+              <a:rPr lang="en-US" sz="1200" b="1" dirty="0">
+                <a:solidFill>
+                  <a:srgbClr val="1B2420"/>
+                </a:solidFill>
+                <a:latin typeface="Cambria" pitchFamily="34" charset="0"/>
+                <a:ea typeface="Cambria" pitchFamily="34" charset="-122"/>
+                <a:cs typeface="Cambria" pitchFamily="34" charset="-120"/>
+              </a:rPr>
+              <a:t>Pertencimento Cultural</a:t>
+            </a:r>
+            <a:endParaRPr lang="en-US" sz="1200" dirty="0"/>
+          </a:p>
+        </p:txBody>
+      </p:sp>
+      <p:sp>
+        <p:nvSpPr>
+          <p:cNvPr id="10" name="Text 8"/>
+          <p:cNvSpPr/>
+          <p:nvPr/>
+        </p:nvSpPr>
+        <p:spPr>
+          <a:xfrm>
+            <a:off x="713232" y="2221992"/>
+            <a:ext cx="7315200" cy="237744"/>
+          </a:xfrm>
+          <a:prstGeom prst="rect">
+            <a:avLst/>
+          </a:prstGeom>
+          <a:noFill/>
+          <a:ln/>
+        </p:spPr>
+        <p:txBody>
+          <a:bodyPr wrap="square" lIns="0" tIns="0" rIns="0" bIns="0" rtlCol="0" anchor="ctr"/>
+          <a:lstStyle/>
+          <a:p>
+            <a:pPr indent="0" marL="0">
+              <a:buNone/>
+            </a:pPr>
+            <a:r>
+              <a:rPr lang="en-US" sz="1000" dirty="0">
+                <a:solidFill>
+                  <a:srgbClr val="8A7070"/>
+                </a:solidFill>
+                <a:latin typeface="Arial" pitchFamily="34" charset="0"/>
+                <a:ea typeface="Arial" pitchFamily="34" charset="-122"/>
+                <a:cs typeface="Arial" pitchFamily="34" charset="-120"/>
+              </a:rPr>
+              <a:t>8 afirmações sobre identificação e conexão com os valores</a:t>
+            </a:r>
+            <a:endParaRPr lang="en-US" sz="1000" dirty="0"/>
+          </a:p>
+        </p:txBody>
+      </p:sp>
+      <p:sp>
+        <p:nvSpPr>
+          <p:cNvPr id="11" name="Shape 9"/>
+          <p:cNvSpPr/>
+          <p:nvPr/>
+        </p:nvSpPr>
+        <p:spPr>
+          <a:xfrm>
+            <a:off x="457200" y="2615184"/>
             <a:ext cx="164592" cy="475488"/>
           </a:xfrm>
           <a:prstGeom prst="rect">
@@ -10311,13 +9630,13 @@
       </p:sp>
       <p:sp>
         <p:nvSpPr>
-          <p:cNvPr id="6" name="Text 4"/>
-          <p:cNvSpPr/>
-          <p:nvPr/>
-        </p:nvSpPr>
-        <p:spPr>
-          <a:xfrm>
-            <a:off x="713232" y="1371600"/>
+          <p:cNvPr id="12" name="Text 10"/>
+          <p:cNvSpPr/>
+          <p:nvPr/>
+        </p:nvSpPr>
+        <p:spPr>
+          <a:xfrm>
+            <a:off x="713232" y="2615184"/>
             <a:ext cx="3200400" cy="237744"/>
           </a:xfrm>
           <a:prstGeom prst="rect">
@@ -10336,218 +9655,12 @@
             <a:r>
               <a:rPr lang="en-US" sz="1200" b="1" dirty="0">
                 <a:solidFill>
-                  <a:srgbClr val="1B2B1E"/>
+                  <a:srgbClr val="1B2420"/>
                 </a:solidFill>
                 <a:latin typeface="Cambria" pitchFamily="34" charset="0"/>
                 <a:ea typeface="Cambria" pitchFamily="34" charset="-122"/>
                 <a:cs typeface="Cambria" pitchFamily="34" charset="-120"/>
               </a:rPr>
-              <a:t>Conhecimento Institucional</a:t>
-            </a:r>
-            <a:endParaRPr lang="en-US" sz="1200" dirty="0"/>
-          </a:p>
-        </p:txBody>
-      </p:sp>
-      <p:sp>
-        <p:nvSpPr>
-          <p:cNvPr id="7" name="Text 5"/>
-          <p:cNvSpPr/>
-          <p:nvPr/>
-        </p:nvSpPr>
-        <p:spPr>
-          <a:xfrm>
-            <a:off x="713232" y="1600200"/>
-            <a:ext cx="7315200" cy="237744"/>
-          </a:xfrm>
-          <a:prstGeom prst="rect">
-            <a:avLst/>
-          </a:prstGeom>
-          <a:noFill/>
-          <a:ln/>
-        </p:spPr>
-        <p:txBody>
-          <a:bodyPr wrap="square" lIns="0" tIns="0" rIns="0" bIns="0" rtlCol="0" anchor="ctr"/>
-          <a:lstStyle/>
-          <a:p>
-            <a:pPr indent="0" marL="0">
-              <a:buNone/>
-            </a:pPr>
-            <a:r>
-              <a:rPr lang="en-US" sz="1000" dirty="0">
-                <a:solidFill>
-                  <a:srgbClr val="748C78"/>
-                </a:solidFill>
-                <a:latin typeface="Calibri" pitchFamily="34" charset="0"/>
-                <a:ea typeface="Calibri" pitchFamily="34" charset="-122"/>
-                <a:cs typeface="Calibri" pitchFamily="34" charset="-120"/>
-              </a:rPr>
-              <a:t>Sim/Não sobre 4 aspectos-chave da escola (missão, processos, pedagogia)</a:t>
-            </a:r>
-            <a:endParaRPr lang="en-US" sz="1000" dirty="0"/>
-          </a:p>
-        </p:txBody>
-      </p:sp>
-      <p:sp>
-        <p:nvSpPr>
-          <p:cNvPr id="8" name="Shape 6"/>
-          <p:cNvSpPr/>
-          <p:nvPr/>
-        </p:nvSpPr>
-        <p:spPr>
-          <a:xfrm>
-            <a:off x="457200" y="1993392"/>
-            <a:ext cx="164592" cy="475488"/>
-          </a:xfrm>
-          <a:prstGeom prst="rect">
-            <a:avLst/>
-          </a:prstGeom>
-          <a:solidFill>
-            <a:srgbClr val="457B9D"/>
-          </a:solidFill>
-          <a:ln w="12700">
-            <a:solidFill>
-              <a:srgbClr val="457B9D"/>
-            </a:solidFill>
-            <a:prstDash val="solid"/>
-          </a:ln>
-        </p:spPr>
-      </p:sp>
-      <p:sp>
-        <p:nvSpPr>
-          <p:cNvPr id="9" name="Text 7"/>
-          <p:cNvSpPr/>
-          <p:nvPr/>
-        </p:nvSpPr>
-        <p:spPr>
-          <a:xfrm>
-            <a:off x="713232" y="1993392"/>
-            <a:ext cx="3200400" cy="237744"/>
-          </a:xfrm>
-          <a:prstGeom prst="rect">
-            <a:avLst/>
-          </a:prstGeom>
-          <a:noFill/>
-          <a:ln/>
-        </p:spPr>
-        <p:txBody>
-          <a:bodyPr wrap="square" lIns="0" tIns="0" rIns="0" bIns="0" rtlCol="0" anchor="ctr"/>
-          <a:lstStyle/>
-          <a:p>
-            <a:pPr indent="0" marL="0">
-              <a:buNone/>
-            </a:pPr>
-            <a:r>
-              <a:rPr lang="en-US" sz="1200" b="1" dirty="0">
-                <a:solidFill>
-                  <a:srgbClr val="1B2B1E"/>
-                </a:solidFill>
-                <a:latin typeface="Cambria" pitchFamily="34" charset="0"/>
-                <a:ea typeface="Cambria" pitchFamily="34" charset="-122"/>
-                <a:cs typeface="Cambria" pitchFamily="34" charset="-120"/>
-              </a:rPr>
-              <a:t>Pertencimento Cultural</a:t>
-            </a:r>
-            <a:endParaRPr lang="en-US" sz="1200" dirty="0"/>
-          </a:p>
-        </p:txBody>
-      </p:sp>
-      <p:sp>
-        <p:nvSpPr>
-          <p:cNvPr id="10" name="Text 8"/>
-          <p:cNvSpPr/>
-          <p:nvPr/>
-        </p:nvSpPr>
-        <p:spPr>
-          <a:xfrm>
-            <a:off x="713232" y="2221992"/>
-            <a:ext cx="7315200" cy="237744"/>
-          </a:xfrm>
-          <a:prstGeom prst="rect">
-            <a:avLst/>
-          </a:prstGeom>
-          <a:noFill/>
-          <a:ln/>
-        </p:spPr>
-        <p:txBody>
-          <a:bodyPr wrap="square" lIns="0" tIns="0" rIns="0" bIns="0" rtlCol="0" anchor="ctr"/>
-          <a:lstStyle/>
-          <a:p>
-            <a:pPr indent="0" marL="0">
-              <a:buNone/>
-            </a:pPr>
-            <a:r>
-              <a:rPr lang="en-US" sz="1000" dirty="0">
-                <a:solidFill>
-                  <a:srgbClr val="748C78"/>
-                </a:solidFill>
-                <a:latin typeface="Calibri" pitchFamily="34" charset="0"/>
-                <a:ea typeface="Calibri" pitchFamily="34" charset="-122"/>
-                <a:cs typeface="Calibri" pitchFamily="34" charset="-120"/>
-              </a:rPr>
-              <a:t>8 afirmações sobre identificação e conexão com os valores da Arandu</a:t>
-            </a:r>
-            <a:endParaRPr lang="en-US" sz="1000" dirty="0"/>
-          </a:p>
-        </p:txBody>
-      </p:sp>
-      <p:sp>
-        <p:nvSpPr>
-          <p:cNvPr id="11" name="Shape 9"/>
-          <p:cNvSpPr/>
-          <p:nvPr/>
-        </p:nvSpPr>
-        <p:spPr>
-          <a:xfrm>
-            <a:off x="457200" y="2615184"/>
-            <a:ext cx="164592" cy="475488"/>
-          </a:xfrm>
-          <a:prstGeom prst="rect">
-            <a:avLst/>
-          </a:prstGeom>
-          <a:solidFill>
-            <a:srgbClr val="2A9D8F"/>
-          </a:solidFill>
-          <a:ln w="12700">
-            <a:solidFill>
-              <a:srgbClr val="2A9D8F"/>
-            </a:solidFill>
-            <a:prstDash val="solid"/>
-          </a:ln>
-        </p:spPr>
-      </p:sp>
-      <p:sp>
-        <p:nvSpPr>
-          <p:cNvPr id="12" name="Text 10"/>
-          <p:cNvSpPr/>
-          <p:nvPr/>
-        </p:nvSpPr>
-        <p:spPr>
-          <a:xfrm>
-            <a:off x="713232" y="2615184"/>
-            <a:ext cx="3200400" cy="237744"/>
-          </a:xfrm>
-          <a:prstGeom prst="rect">
-            <a:avLst/>
-          </a:prstGeom>
-          <a:noFill/>
-          <a:ln/>
-        </p:spPr>
-        <p:txBody>
-          <a:bodyPr wrap="square" lIns="0" tIns="0" rIns="0" bIns="0" rtlCol="0" anchor="ctr"/>
-          <a:lstStyle/>
-          <a:p>
-            <a:pPr indent="0" marL="0">
-              <a:buNone/>
-            </a:pPr>
-            <a:r>
-              <a:rPr lang="en-US" sz="1200" b="1" dirty="0">
-                <a:solidFill>
-                  <a:srgbClr val="1B2B1E"/>
-                </a:solidFill>
-                <a:latin typeface="Cambria" pitchFamily="34" charset="0"/>
-                <a:ea typeface="Cambria" pitchFamily="34" charset="-122"/>
-                <a:cs typeface="Cambria" pitchFamily="34" charset="-120"/>
-              </a:rPr>
               <a:t>Acordos Sociais</a:t>
             </a:r>
             <a:endParaRPr lang="en-US" sz="1200" dirty="0"/>
@@ -10581,11 +9694,11 @@
             <a:r>
               <a:rPr lang="en-US" sz="1000" dirty="0">
                 <a:solidFill>
-                  <a:srgbClr val="748C78"/>
-                </a:solidFill>
-                <a:latin typeface="Calibri" pitchFamily="34" charset="0"/>
-                <a:ea typeface="Calibri" pitchFamily="34" charset="-122"/>
-                <a:cs typeface="Calibri" pitchFamily="34" charset="-120"/>
+                  <a:srgbClr val="8A7070"/>
+                </a:solidFill>
+                <a:latin typeface="Arial" pitchFamily="34" charset="0"/>
+                <a:ea typeface="Arial" pitchFamily="34" charset="-122"/>
+                <a:cs typeface="Arial" pitchFamily="34" charset="-120"/>
               </a:rPr>
               <a:t>9 afirmações sobre práticas comunitárias e acordos coletivos</a:t>
             </a:r>
@@ -10645,7 +9758,7 @@
             <a:r>
               <a:rPr lang="en-US" sz="1200" b="1" dirty="0">
                 <a:solidFill>
-                  <a:srgbClr val="1B2B1E"/>
+                  <a:srgbClr val="1B2420"/>
                 </a:solidFill>
                 <a:latin typeface="Cambria" pitchFamily="34" charset="0"/>
                 <a:ea typeface="Cambria" pitchFamily="34" charset="-122"/>
@@ -10684,11 +9797,11 @@
             <a:r>
               <a:rPr lang="en-US" sz="1000" dirty="0">
                 <a:solidFill>
-                  <a:srgbClr val="748C78"/>
-                </a:solidFill>
-                <a:latin typeface="Calibri" pitchFamily="34" charset="0"/>
-                <a:ea typeface="Calibri" pitchFamily="34" charset="-122"/>
-                <a:cs typeface="Calibri" pitchFamily="34" charset="-120"/>
+                  <a:srgbClr val="8A7070"/>
+                </a:solidFill>
+                <a:latin typeface="Arial" pitchFamily="34" charset="0"/>
+                <a:ea typeface="Arial" pitchFamily="34" charset="-122"/>
+                <a:cs typeface="Arial" pitchFamily="34" charset="-120"/>
               </a:rPr>
               <a:t>8 afirmações sobre práticas de economia solidária e doação</a:t>
             </a:r>
@@ -10748,7 +9861,7 @@
             <a:r>
               <a:rPr lang="en-US" sz="1200" b="1" dirty="0">
                 <a:solidFill>
-                  <a:srgbClr val="1B2B1E"/>
+                  <a:srgbClr val="1B2420"/>
                 </a:solidFill>
                 <a:latin typeface="Cambria" pitchFamily="34" charset="0"/>
                 <a:ea typeface="Cambria" pitchFamily="34" charset="-122"/>
@@ -10787,11 +9900,11 @@
             <a:r>
               <a:rPr lang="en-US" sz="1000" dirty="0">
                 <a:solidFill>
-                  <a:srgbClr val="748C78"/>
-                </a:solidFill>
-                <a:latin typeface="Calibri" pitchFamily="34" charset="0"/>
-                <a:ea typeface="Calibri" pitchFamily="34" charset="-122"/>
-                <a:cs typeface="Calibri" pitchFamily="34" charset="-120"/>
+                  <a:srgbClr val="8A7070"/>
+                </a:solidFill>
+                <a:latin typeface="Arial" pitchFamily="34" charset="0"/>
+                <a:ea typeface="Arial" pitchFamily="34" charset="-122"/>
+                <a:cs typeface="Arial" pitchFamily="34" charset="-120"/>
               </a:rPr>
               <a:t>5 papéis institucionais: Sou atualmente / Já fui / Nunca fui</a:t>
             </a:r>
@@ -10814,11 +9927,11 @@
             <a:avLst/>
           </a:prstGeom>
           <a:solidFill>
-            <a:srgbClr val="F4FAF7"/>
+            <a:srgbClr val="FDF6F4"/>
           </a:solidFill>
           <a:ln w="12700">
             <a:solidFill>
-              <a:srgbClr val="B7E4C7"/>
+              <a:srgbClr val="E8D5D0"/>
             </a:solidFill>
             <a:prstDash val="solid"/>
           </a:ln>
@@ -10851,13 +9964,13 @@
             <a:r>
               <a:rPr lang="en-US" sz="950" dirty="0">
                 <a:solidFill>
-                  <a:srgbClr val="1B2B1E"/>
-                </a:solidFill>
-                <a:latin typeface="Calibri" pitchFamily="34" charset="0"/>
-                <a:ea typeface="Calibri" pitchFamily="34" charset="-122"/>
-                <a:cs typeface="Calibri" pitchFamily="34" charset="-120"/>
-              </a:rPr>
-              <a:t>Net Signal: Concordo×1,0 + Concordo parc.×0,4 + Não sei×(−0,2) + Discordo×(−0,8) → normalizado [0, 1]. Modificadores: novatos (≤1 ano) limitados ao estágio Inserindo; veteranos (≥5 anos) sem comprometimento → Inserindo/Adaptando.</a:t>
+                  <a:srgbClr val="1B2420"/>
+                </a:solidFill>
+                <a:latin typeface="Arial" pitchFamily="34" charset="0"/>
+                <a:ea typeface="Arial" pitchFamily="34" charset="-122"/>
+                <a:cs typeface="Arial" pitchFamily="34" charset="-120"/>
+              </a:rPr>
+              <a:t>Net Signal: Concordo×1,0 + Concordo parc.×0,4 + Não sei×(−0,2) + Discordo×(−0,8) → normalizado [0, 1]. Modificadores: novatos (≤1 ano) limitados a Inserindo; veteranos (≥5 anos) sem comprometimento → Inserindo/Adaptando.</a:t>
             </a:r>
             <a:endParaRPr lang="en-US" sz="950" dirty="0"/>
           </a:p>
@@ -10922,7 +10035,7 @@
             <a:r>
               <a:rPr lang="en-US" sz="2600" b="1" dirty="0">
                 <a:solidFill>
-                  <a:srgbClr val="1B4332"/>
+                  <a:srgbClr val="7B2230"/>
                 </a:solidFill>
                 <a:latin typeface="Cambria" pitchFamily="34" charset="0"/>
                 <a:ea typeface="Cambria" pitchFamily="34" charset="-122"/>
@@ -10961,13 +10074,13 @@
             <a:r>
               <a:rPr lang="en-US" sz="1200" i="1" dirty="0">
                 <a:solidFill>
-                  <a:srgbClr val="748C78"/>
-                </a:solidFill>
-                <a:latin typeface="Calibri" pitchFamily="34" charset="0"/>
-                <a:ea typeface="Calibri" pitchFamily="34" charset="-122"/>
-                <a:cs typeface="Calibri" pitchFamily="34" charset="-120"/>
-              </a:rPr>
-              <a:t>Posicionamento inferido de cada respondente com base nas respostas — N = 143</a:t>
+                  <a:srgbClr val="8A7070"/>
+                </a:solidFill>
+                <a:latin typeface="Arial" pitchFamily="34" charset="0"/>
+                <a:ea typeface="Arial" pitchFamily="34" charset="-122"/>
+                <a:cs typeface="Arial" pitchFamily="34" charset="-120"/>
+              </a:rPr>
+              <a:t>Posicionamento inferido com base nas respostas — N = 143</a:t>
             </a:r>
             <a:endParaRPr lang="en-US" sz="1200" dirty="0"/>
           </a:p>
@@ -11004,11 +10117,11 @@
             <a:avLst/>
           </a:prstGeom>
           <a:solidFill>
-            <a:srgbClr val="F4FAF7"/>
+            <a:srgbClr val="FDF6F4"/>
           </a:solidFill>
           <a:ln w="12700">
             <a:solidFill>
-              <a:srgbClr val="F4845F"/>
+              <a:srgbClr val="C04060"/>
             </a:solidFill>
             <a:prstDash val="solid"/>
           </a:ln>
@@ -11029,11 +10142,11 @@
             <a:avLst/>
           </a:prstGeom>
           <a:solidFill>
-            <a:srgbClr val="F4845F"/>
+            <a:srgbClr val="C04060"/>
           </a:solidFill>
           <a:ln w="12700">
             <a:solidFill>
-              <a:srgbClr val="F4845F"/>
+              <a:srgbClr val="C04060"/>
             </a:solidFill>
             <a:prstDash val="solid"/>
           </a:ln>
@@ -11068,9 +10181,9 @@
                 <a:solidFill>
                   <a:srgbClr val="FFFFFF"/>
                 </a:solidFill>
-                <a:latin typeface="Calibri" pitchFamily="34" charset="0"/>
-                <a:ea typeface="Calibri" pitchFamily="34" charset="-122"/>
-                <a:cs typeface="Calibri" pitchFamily="34" charset="-120"/>
+                <a:latin typeface="Arial" pitchFamily="34" charset="0"/>
+                <a:ea typeface="Arial" pitchFamily="34" charset="-122"/>
+                <a:cs typeface="Arial" pitchFamily="34" charset="-120"/>
               </a:rPr>
               <a:t>Inserindo</a:t>
             </a:r>
@@ -11105,7 +10218,7 @@
             <a:r>
               <a:rPr lang="en-US" sz="3000" b="1" dirty="0">
                 <a:solidFill>
-                  <a:srgbClr val="F4845F"/>
+                  <a:srgbClr val="C04060"/>
                 </a:solidFill>
                 <a:latin typeface="Cambria" pitchFamily="34" charset="0"/>
                 <a:ea typeface="Cambria" pitchFamily="34" charset="-122"/>
@@ -11144,11 +10257,11 @@
             <a:r>
               <a:rPr lang="en-US" sz="1100" dirty="0">
                 <a:solidFill>
-                  <a:srgbClr val="748C78"/>
-                </a:solidFill>
-                <a:latin typeface="Calibri" pitchFamily="34" charset="0"/>
-                <a:ea typeface="Calibri" pitchFamily="34" charset="-122"/>
-                <a:cs typeface="Calibri" pitchFamily="34" charset="-120"/>
+                  <a:srgbClr val="8A7070"/>
+                </a:solidFill>
+                <a:latin typeface="Arial" pitchFamily="34" charset="0"/>
+                <a:ea typeface="Arial" pitchFamily="34" charset="-122"/>
+                <a:cs typeface="Arial" pitchFamily="34" charset="-120"/>
               </a:rPr>
               <a:t>N = 46</a:t>
             </a:r>
@@ -11164,7 +10277,7 @@
         </p:nvSpPr>
         <p:spPr>
           <a:xfrm>
-            <a:off x="530352" y="3822192"/>
+            <a:off x="530352" y="3877056"/>
             <a:ext cx="1901952" cy="548640"/>
           </a:xfrm>
           <a:prstGeom prst="rect">
@@ -11183,11 +10296,11 @@
             <a:r>
               <a:rPr lang="en-US" sz="950" dirty="0">
                 <a:solidFill>
-                  <a:srgbClr val="1B2B1E"/>
-                </a:solidFill>
-                <a:latin typeface="Calibri" pitchFamily="34" charset="0"/>
-                <a:ea typeface="Calibri" pitchFamily="34" charset="-122"/>
-                <a:cs typeface="Calibri" pitchFamily="34" charset="-120"/>
+                  <a:srgbClr val="1B2420"/>
+                </a:solidFill>
+                <a:latin typeface="Arial" pitchFamily="34" charset="0"/>
+                <a:ea typeface="Arial" pitchFamily="34" charset="-122"/>
+                <a:cs typeface="Arial" pitchFamily="34" charset="-120"/>
               </a:rPr>
               <a:t>No ponto de virada — decidir SIM ou NÃO</a:t>
             </a:r>
@@ -11210,7 +10323,7 @@
             <a:avLst/>
           </a:prstGeom>
           <a:solidFill>
-            <a:srgbClr val="F4FAF7"/>
+            <a:srgbClr val="FDF6F4"/>
           </a:solidFill>
           <a:ln w="12700">
             <a:solidFill>
@@ -11274,9 +10387,9 @@
                 <a:solidFill>
                   <a:srgbClr val="FFFFFF"/>
                 </a:solidFill>
-                <a:latin typeface="Calibri" pitchFamily="34" charset="0"/>
-                <a:ea typeface="Calibri" pitchFamily="34" charset="-122"/>
-                <a:cs typeface="Calibri" pitchFamily="34" charset="-120"/>
+                <a:latin typeface="Arial" pitchFamily="34" charset="0"/>
+                <a:ea typeface="Arial" pitchFamily="34" charset="-122"/>
+                <a:cs typeface="Arial" pitchFamily="34" charset="-120"/>
               </a:rPr>
               <a:t>Comprometido</a:t>
             </a:r>
@@ -11350,11 +10463,11 @@
             <a:r>
               <a:rPr lang="en-US" sz="1100" dirty="0">
                 <a:solidFill>
-                  <a:srgbClr val="748C78"/>
-                </a:solidFill>
-                <a:latin typeface="Calibri" pitchFamily="34" charset="0"/>
-                <a:ea typeface="Calibri" pitchFamily="34" charset="-122"/>
-                <a:cs typeface="Calibri" pitchFamily="34" charset="-120"/>
+                  <a:srgbClr val="8A7070"/>
+                </a:solidFill>
+                <a:latin typeface="Arial" pitchFamily="34" charset="0"/>
+                <a:ea typeface="Arial" pitchFamily="34" charset="-122"/>
+                <a:cs typeface="Arial" pitchFamily="34" charset="-120"/>
               </a:rPr>
               <a:t>N = 64</a:t>
             </a:r>
@@ -11370,7 +10483,7 @@
         </p:nvSpPr>
         <p:spPr>
           <a:xfrm>
-            <a:off x="2706624" y="3822192"/>
+            <a:off x="2706624" y="3877056"/>
             <a:ext cx="1901952" cy="548640"/>
           </a:xfrm>
           <a:prstGeom prst="rect">
@@ -11389,13 +10502,13 @@
             <a:r>
               <a:rPr lang="en-US" sz="950" dirty="0">
                 <a:solidFill>
-                  <a:srgbClr val="1B2B1E"/>
-                </a:solidFill>
-                <a:latin typeface="Calibri" pitchFamily="34" charset="0"/>
-                <a:ea typeface="Calibri" pitchFamily="34" charset="-122"/>
-                <a:cs typeface="Calibri" pitchFamily="34" charset="-120"/>
-              </a:rPr>
-              <a:t>Disse SIM, sem papel ativo ainda</a:t>
+                  <a:srgbClr val="1B2420"/>
+                </a:solidFill>
+                <a:latin typeface="Arial" pitchFamily="34" charset="0"/>
+                <a:ea typeface="Arial" pitchFamily="34" charset="-122"/>
+                <a:cs typeface="Arial" pitchFamily="34" charset="-120"/>
+              </a:rPr>
+              <a:t>Disse SIM, sem papel ativo estruturado</a:t>
             </a:r>
             <a:endParaRPr lang="en-US" sz="950" dirty="0"/>
           </a:p>
@@ -11416,7 +10529,7 @@
             <a:avLst/>
           </a:prstGeom>
           <a:solidFill>
-            <a:srgbClr val="F4FAF7"/>
+            <a:srgbClr val="FDF6F4"/>
           </a:solidFill>
           <a:ln w="12700">
             <a:solidFill>
@@ -11480,9 +10593,9 @@
                 <a:solidFill>
                   <a:srgbClr val="FFFFFF"/>
                 </a:solidFill>
-                <a:latin typeface="Calibri" pitchFamily="34" charset="0"/>
-                <a:ea typeface="Calibri" pitchFamily="34" charset="-122"/>
-                <a:cs typeface="Calibri" pitchFamily="34" charset="-120"/>
+                <a:latin typeface="Arial" pitchFamily="34" charset="0"/>
+                <a:ea typeface="Arial" pitchFamily="34" charset="-122"/>
+                <a:cs typeface="Arial" pitchFamily="34" charset="-120"/>
               </a:rPr>
               <a:t>Ativo no Motivo</a:t>
             </a:r>
@@ -11556,11 +10669,11 @@
             <a:r>
               <a:rPr lang="en-US" sz="1100" dirty="0">
                 <a:solidFill>
-                  <a:srgbClr val="748C78"/>
-                </a:solidFill>
-                <a:latin typeface="Calibri" pitchFamily="34" charset="0"/>
-                <a:ea typeface="Calibri" pitchFamily="34" charset="-122"/>
-                <a:cs typeface="Calibri" pitchFamily="34" charset="-120"/>
+                  <a:srgbClr val="8A7070"/>
+                </a:solidFill>
+                <a:latin typeface="Arial" pitchFamily="34" charset="0"/>
+                <a:ea typeface="Arial" pitchFamily="34" charset="-122"/>
+                <a:cs typeface="Arial" pitchFamily="34" charset="-120"/>
               </a:rPr>
               <a:t>N = 17</a:t>
             </a:r>
@@ -11576,7 +10689,7 @@
         </p:nvSpPr>
         <p:spPr>
           <a:xfrm>
-            <a:off x="4882896" y="3822192"/>
+            <a:off x="4882896" y="3877056"/>
             <a:ext cx="1901952" cy="548640"/>
           </a:xfrm>
           <a:prstGeom prst="rect">
@@ -11595,13 +10708,13 @@
             <a:r>
               <a:rPr lang="en-US" sz="950" dirty="0">
                 <a:solidFill>
-                  <a:srgbClr val="1B2B1E"/>
-                </a:solidFill>
-                <a:latin typeface="Calibri" pitchFamily="34" charset="0"/>
-                <a:ea typeface="Calibri" pitchFamily="34" charset="-122"/>
-                <a:cs typeface="Calibri" pitchFamily="34" charset="-120"/>
-              </a:rPr>
-              <a:t>Engajado com papel(s) ativo(s)</a:t>
+                  <a:srgbClr val="1B2420"/>
+                </a:solidFill>
+                <a:latin typeface="Arial" pitchFamily="34" charset="0"/>
+                <a:ea typeface="Arial" pitchFamily="34" charset="-122"/>
+                <a:cs typeface="Arial" pitchFamily="34" charset="-120"/>
+              </a:rPr>
+              <a:t>Engajado com ao menos 1 papel ativo</a:t>
             </a:r>
             <a:endParaRPr lang="en-US" sz="950" dirty="0"/>
           </a:p>
@@ -11622,7 +10735,7 @@
             <a:avLst/>
           </a:prstGeom>
           <a:solidFill>
-            <a:srgbClr val="F4FAF7"/>
+            <a:srgbClr val="FDF6F4"/>
           </a:solidFill>
           <a:ln w="12700">
             <a:solidFill>
@@ -11686,9 +10799,9 @@
                 <a:solidFill>
                   <a:srgbClr val="FFFFFF"/>
                 </a:solidFill>
-                <a:latin typeface="Calibri" pitchFamily="34" charset="0"/>
-                <a:ea typeface="Calibri" pitchFamily="34" charset="-122"/>
-                <a:cs typeface="Calibri" pitchFamily="34" charset="-120"/>
+                <a:latin typeface="Arial" pitchFamily="34" charset="0"/>
+                <a:ea typeface="Arial" pitchFamily="34" charset="-122"/>
+                <a:cs typeface="Arial" pitchFamily="34" charset="-120"/>
               </a:rPr>
               <a:t>Emb + Coc</a:t>
             </a:r>
@@ -11762,11 +10875,11 @@
             <a:r>
               <a:rPr lang="en-US" sz="1100" dirty="0">
                 <a:solidFill>
-                  <a:srgbClr val="748C78"/>
-                </a:solidFill>
-                <a:latin typeface="Calibri" pitchFamily="34" charset="0"/>
-                <a:ea typeface="Calibri" pitchFamily="34" charset="-122"/>
-                <a:cs typeface="Calibri" pitchFamily="34" charset="-120"/>
+                  <a:srgbClr val="8A7070"/>
+                </a:solidFill>
+                <a:latin typeface="Arial" pitchFamily="34" charset="0"/>
+                <a:ea typeface="Arial" pitchFamily="34" charset="-122"/>
+                <a:cs typeface="Arial" pitchFamily="34" charset="-120"/>
               </a:rPr>
               <a:t>N = 15</a:t>
             </a:r>
@@ -11782,7 +10895,7 @@
         </p:nvSpPr>
         <p:spPr>
           <a:xfrm>
-            <a:off x="7059168" y="3822192"/>
+            <a:off x="7059168" y="3877056"/>
             <a:ext cx="1901952" cy="548640"/>
           </a:xfrm>
           <a:prstGeom prst="rect">
@@ -11801,11 +10914,11 @@
             <a:r>
               <a:rPr lang="en-US" sz="950" dirty="0">
                 <a:solidFill>
-                  <a:srgbClr val="1B2B1E"/>
-                </a:solidFill>
-                <a:latin typeface="Calibri" pitchFamily="34" charset="0"/>
-                <a:ea typeface="Calibri" pitchFamily="34" charset="-122"/>
-                <a:cs typeface="Calibri" pitchFamily="34" charset="-120"/>
+                  <a:srgbClr val="1B2420"/>
+                </a:solidFill>
+                <a:latin typeface="Arial" pitchFamily="34" charset="0"/>
+                <a:ea typeface="Arial" pitchFamily="34" charset="-122"/>
+                <a:cs typeface="Arial" pitchFamily="34" charset="-120"/>
               </a:rPr>
               <a:t>Referências comunitárias e co-criadores</a:t>
             </a:r>

</xml_diff>